<commit_message>
docs: add embedded HD architectural diagram images for DDD, Car Analogy, and Hexagonal Codebase to PPTX
</commit_message>
<xml_diff>
--- a/Satellite_Architecture_DDD_Hexagonal_ArchUnit.pptx
+++ b/Satellite_Architecture_DDD_Hexagonal_ArchUnit.pptx
@@ -3749,7 +3749,7 @@
                   <a:srgbClr val="94A3B8"/>
                 </a:solidFill>
               </a:rPr>
-              <a:t>Over time, Controllers bypass Services to call DAOs, creating cyclic dependencies and untestable spaghetti code.</a:t>
+              <a:t>Over time, Controllers bypass Services to call DAOs, creating cyclic dependencies and untestable code.</a:t>
             </a:r>
           </a:p>
           <a:p>
@@ -3945,7 +3945,7 @@
               </a:defRPr>
             </a:pPr>
             <a:r>
-              <a:t>PURE BUSINESS LOGIC</a:t>
+              <a:t>PURE BUSINESS LOGIC CORE</a:t>
             </a:r>
           </a:p>
           <a:p>
@@ -3958,365 +3958,35 @@
               </a:defRPr>
             </a:pPr>
             <a:r>
-              <a:t>Pillar 1: Domain-Driven Design (DDD) Core</a:t>
-            </a:r>
-          </a:p>
-        </p:txBody>
-      </p:sp>
-      <p:sp>
-        <p:nvSpPr>
-          <p:cNvPr id="3" name="Rounded Rectangle 2"/>
-          <p:cNvSpPr/>
+              <a:t>Pillar 1: Domain-Driven Design (DDD) Architecture</a:t>
+            </a:r>
+          </a:p>
+        </p:txBody>
+      </p:sp>
+      <p:pic>
+        <p:nvPicPr>
+          <p:cNvPr id="3" name="Picture 2" descr="diagram_ddd.png"/>
+          <p:cNvPicPr>
+            <a:picLocks noChangeAspect="1"/>
+          </p:cNvPicPr>
           <p:nvPr/>
-        </p:nvSpPr>
+        </p:nvPicPr>
+        <p:blipFill>
+          <a:blip r:embed="rId2"/>
+          <a:stretch>
+            <a:fillRect/>
+          </a:stretch>
+        </p:blipFill>
         <p:spPr>
           <a:xfrm>
             <a:off x="731520" y="1371600"/>
-            <a:ext cx="5486400" cy="4754880"/>
+            <a:ext cx="10698480" cy="4937760"/>
           </a:xfrm>
-          <a:prstGeom prst="roundRect">
+          <a:prstGeom prst="rect">
             <a:avLst/>
           </a:prstGeom>
-          <a:solidFill>
-            <a:srgbClr val="1E293B"/>
-          </a:solidFill>
-          <a:ln w="19050">
-            <a:solidFill>
-              <a:srgbClr val="334155"/>
-            </a:solidFill>
-          </a:ln>
         </p:spPr>
-        <p:style>
-          <a:lnRef idx="1">
-            <a:schemeClr val="accent1"/>
-          </a:lnRef>
-          <a:fillRef idx="3">
-            <a:schemeClr val="accent1"/>
-          </a:fillRef>
-          <a:effectRef idx="2">
-            <a:schemeClr val="accent1"/>
-          </a:effectRef>
-          <a:fontRef idx="minor">
-            <a:schemeClr val="lt1"/>
-          </a:fontRef>
-        </p:style>
-        <p:txBody>
-          <a:bodyPr rtlCol="0" anchor="ctr" wrap="square"/>
-          <a:lstStyle/>
-          <a:p>
-            <a:pPr algn="ctr">
-              <a:defRPr b="1" sz="1800">
-                <a:solidFill>
-                  <a:srgbClr val="3B82F6"/>
-                </a:solidFill>
-              </a:defRPr>
-            </a:pPr>
-            <a:r>
-              <a:t>Standalone Domain Architecture</a:t>
-            </a:r>
-          </a:p>
-          <a:p>
-            <a:pPr>
-              <a:defRPr b="1" sz="1300">
-                <a:solidFill>
-                  <a:srgbClr val="F8FAFC"/>
-                </a:solidFill>
-              </a:defRPr>
-            </a:pPr>
-            <a:r>
-              <a:t>✔ Domain Core (Heart): </a:t>
-            </a:r>
-            <a:r>
-              <a:rPr b="0">
-                <a:solidFill>
-                  <a:srgbClr val="94A3B8"/>
-                </a:solidFill>
-              </a:rPr>
-              <a:t>Contains Aggregate Root (Satellite), Value Objects (Orbit, Telemetry), and Domain Events.</a:t>
-            </a:r>
-          </a:p>
-          <a:p>
-            <a:pPr>
-              <a:defRPr b="1" sz="1300">
-                <a:solidFill>
-                  <a:srgbClr val="F8FAFC"/>
-                </a:solidFill>
-              </a:defRPr>
-            </a:pPr>
-            <a:r>
-              <a:t>✔ Zero Annotations: </a:t>
-            </a:r>
-            <a:r>
-              <a:rPr b="0">
-                <a:solidFill>
-                  <a:srgbClr val="94A3B8"/>
-                </a:solidFill>
-              </a:rPr>
-              <a:t>No @Entity, @Table, @Component, or @JsonProperty. 100% pure Java code.</a:t>
-            </a:r>
-          </a:p>
-          <a:p>
-            <a:pPr>
-              <a:defRPr b="1" sz="1300">
-                <a:solidFill>
-                  <a:srgbClr val="F8FAFC"/>
-                </a:solidFill>
-              </a:defRPr>
-            </a:pPr>
-            <a:r>
-              <a:t>✔ Rich Domain Invariants: </a:t>
-            </a:r>
-            <a:r>
-              <a:rPr b="0">
-                <a:solidFill>
-                  <a:srgbClr val="94A3B8"/>
-                </a:solidFill>
-              </a:rPr>
-              <a:t>State transitions (REGISTERED -&gt; ACTIVE -&gt; ANOMALY) are controlled internally by the aggregate.</a:t>
-            </a:r>
-          </a:p>
-          <a:p>
-            <a:pPr>
-              <a:defRPr b="1" sz="1300">
-                <a:solidFill>
-                  <a:srgbClr val="F8FAFC"/>
-                </a:solidFill>
-              </a:defRPr>
-            </a:pPr>
-            <a:r>
-              <a:t>✔ Self-Validating Value Objects: </a:t>
-            </a:r>
-            <a:r>
-              <a:rPr b="0">
-                <a:solidFill>
-                  <a:srgbClr val="94A3B8"/>
-                </a:solidFill>
-              </a:rPr>
-              <a:t>Orbit validates altitude constraints (LEO &lt; 2000 km, GEO ~35,786 km) at instant of creation.</a:t>
-            </a:r>
-          </a:p>
-        </p:txBody>
-      </p:sp>
-      <p:sp>
-        <p:nvSpPr>
-          <p:cNvPr id="4" name="Rounded Rectangle 3"/>
-          <p:cNvSpPr/>
-          <p:nvPr/>
-        </p:nvSpPr>
-        <p:spPr>
-          <a:xfrm>
-            <a:off x="6492240" y="1371600"/>
-            <a:ext cx="4937760" cy="4754880"/>
-          </a:xfrm>
-          <a:prstGeom prst="roundRect">
-            <a:avLst/>
-          </a:prstGeom>
-          <a:solidFill>
-            <a:srgbClr val="1E293B"/>
-          </a:solidFill>
-          <a:ln w="19050">
-            <a:solidFill>
-              <a:srgbClr val="334155"/>
-            </a:solidFill>
-          </a:ln>
-        </p:spPr>
-        <p:style>
-          <a:lnRef idx="1">
-            <a:schemeClr val="accent1"/>
-          </a:lnRef>
-          <a:fillRef idx="3">
-            <a:schemeClr val="accent1"/>
-          </a:fillRef>
-          <a:effectRef idx="2">
-            <a:schemeClr val="accent1"/>
-          </a:effectRef>
-          <a:fontRef idx="minor">
-            <a:schemeClr val="lt1"/>
-          </a:fontRef>
-        </p:style>
-        <p:txBody>
-          <a:bodyPr rtlCol="0" anchor="ctr" wrap="square"/>
-          <a:lstStyle/>
-          <a:p>
-            <a:pPr algn="ctr">
-              <a:defRPr b="1" sz="1600">
-                <a:solidFill>
-                  <a:srgbClr val="10B981"/>
-                </a:solidFill>
-              </a:defRPr>
-            </a:pPr>
-            <a:r>
-              <a:t>Code Snippet: Pure Java Aggregate</a:t>
-            </a:r>
-          </a:p>
-          <a:p>
-            <a:pPr>
-              <a:defRPr sz="1200">
-                <a:solidFill>
-                  <a:srgbClr val="F8FAFC"/>
-                </a:solidFill>
-                <a:latin typeface="Courier New"/>
-              </a:defRPr>
-            </a:pPr>
-            <a:r>
-              <a:t>// Pure Java Aggregate Root</a:t>
-            </a:r>
-          </a:p>
-          <a:p>
-            <a:pPr>
-              <a:defRPr sz="1200">
-                <a:solidFill>
-                  <a:srgbClr val="F8FAFC"/>
-                </a:solidFill>
-                <a:latin typeface="Courier New"/>
-              </a:defRPr>
-            </a:pPr>
-            <a:r>
-              <a:t>public class Satellite {</a:t>
-            </a:r>
-          </a:p>
-          <a:p>
-            <a:pPr>
-              <a:defRPr sz="1200">
-                <a:solidFill>
-                  <a:srgbClr val="F8FAFC"/>
-                </a:solidFill>
-                <a:latin typeface="Courier New"/>
-              </a:defRPr>
-            </a:pPr>
-            <a:r>
-              <a:t>  private final SatelliteId id;</a:t>
-            </a:r>
-          </a:p>
-          <a:p>
-            <a:pPr>
-              <a:defRPr sz="1200">
-                <a:solidFill>
-                  <a:srgbClr val="F8FAFC"/>
-                </a:solidFill>
-                <a:latin typeface="Courier New"/>
-              </a:defRPr>
-            </a:pPr>
-            <a:r>
-              <a:t>  private Orbit orbit;</a:t>
-            </a:r>
-          </a:p>
-          <a:p>
-            <a:pPr>
-              <a:defRPr sz="1200">
-                <a:solidFill>
-                  <a:srgbClr val="F8FAFC"/>
-                </a:solidFill>
-                <a:latin typeface="Courier New"/>
-              </a:defRPr>
-            </a:pPr>
-            <a:r>
-              <a:t>  private SatelliteStatus status;</a:t>
-            </a:r>
-          </a:p>
-          <a:p>
-            <a:pPr>
-              <a:defRPr sz="1200">
-                <a:solidFill>
-                  <a:srgbClr val="F8FAFC"/>
-                </a:solidFill>
-                <a:latin typeface="Courier New"/>
-              </a:defRPr>
-            </a:pPr>
-          </a:p>
-          <a:p>
-            <a:pPr>
-              <a:defRPr sz="1200">
-                <a:solidFill>
-                  <a:srgbClr val="F8FAFC"/>
-                </a:solidFill>
-                <a:latin typeface="Courier New"/>
-              </a:defRPr>
-            </a:pPr>
-            <a:r>
-              <a:t>  public void launch() {</a:t>
-            </a:r>
-          </a:p>
-          <a:p>
-            <a:pPr>
-              <a:defRPr sz="1200">
-                <a:solidFill>
-                  <a:srgbClr val="F8FAFC"/>
-                </a:solidFill>
-                <a:latin typeface="Courier New"/>
-              </a:defRPr>
-            </a:pPr>
-            <a:r>
-              <a:t>    ensureCanTransitionTo(ACTIVE);</a:t>
-            </a:r>
-          </a:p>
-          <a:p>
-            <a:pPr>
-              <a:defRPr sz="1200">
-                <a:solidFill>
-                  <a:srgbClr val="F8FAFC"/>
-                </a:solidFill>
-                <a:latin typeface="Courier New"/>
-              </a:defRPr>
-            </a:pPr>
-            <a:r>
-              <a:t>    this.status = ACTIVE;</a:t>
-            </a:r>
-          </a:p>
-          <a:p>
-            <a:pPr>
-              <a:defRPr sz="1200">
-                <a:solidFill>
-                  <a:srgbClr val="F8FAFC"/>
-                </a:solidFill>
-                <a:latin typeface="Courier New"/>
-              </a:defRPr>
-            </a:pPr>
-            <a:r>
-              <a:t>    this.domainEvents.add(</a:t>
-            </a:r>
-          </a:p>
-          <a:p>
-            <a:pPr>
-              <a:defRPr sz="1200">
-                <a:solidFill>
-                  <a:srgbClr val="F8FAFC"/>
-                </a:solidFill>
-                <a:latin typeface="Courier New"/>
-              </a:defRPr>
-            </a:pPr>
-            <a:r>
-              <a:t>      new SatelliteLaunchedEvent(...));</a:t>
-            </a:r>
-          </a:p>
-          <a:p>
-            <a:pPr>
-              <a:defRPr sz="1200">
-                <a:solidFill>
-                  <a:srgbClr val="F8FAFC"/>
-                </a:solidFill>
-                <a:latin typeface="Courier New"/>
-              </a:defRPr>
-            </a:pPr>
-            <a:r>
-              <a:t>  }</a:t>
-            </a:r>
-          </a:p>
-          <a:p>
-            <a:pPr>
-              <a:defRPr sz="1200">
-                <a:solidFill>
-                  <a:srgbClr val="F8FAFC"/>
-                </a:solidFill>
-                <a:latin typeface="Courier New"/>
-              </a:defRPr>
-            </a:pPr>
-            <a:r>
-              <a:t>}</a:t>
-            </a:r>
-          </a:p>
-        </p:txBody>
-      </p:sp>
+      </p:pic>
     </p:spTree>
   </p:cSld>
   <p:clrMapOvr>
@@ -4374,7 +4044,7 @@
               </a:defRPr>
             </a:pPr>
             <a:r>
-              <a:t>PORTS &amp; ADAPTERS CONCEPT</a:t>
+              <a:t>PORTS &amp; ADAPTERS CONCEPTUAL MODEL</a:t>
             </a:r>
           </a:p>
           <a:p>
@@ -4387,303 +4057,35 @@
               </a:defRPr>
             </a:pPr>
             <a:r>
-              <a:t>Pillar 2A: Hexagonal Architecture (Real-World Car Analogy)</a:t>
-            </a:r>
-          </a:p>
-        </p:txBody>
-      </p:sp>
-      <p:sp>
-        <p:nvSpPr>
-          <p:cNvPr id="3" name="Rounded Rectangle 2"/>
-          <p:cNvSpPr/>
+              <a:t>Pillar 2A: Hexagonal Architecture Concept (Real-World Car Analogy)</a:t>
+            </a:r>
+          </a:p>
+        </p:txBody>
+      </p:sp>
+      <p:pic>
+        <p:nvPicPr>
+          <p:cNvPr id="3" name="Picture 2" descr="diagram_car_analogy.png"/>
+          <p:cNvPicPr>
+            <a:picLocks noChangeAspect="1"/>
+          </p:cNvPicPr>
           <p:nvPr/>
-        </p:nvSpPr>
+        </p:nvPicPr>
+        <p:blipFill>
+          <a:blip r:embed="rId2"/>
+          <a:stretch>
+            <a:fillRect/>
+          </a:stretch>
+        </p:blipFill>
         <p:spPr>
           <a:xfrm>
-            <a:off x="731520" y="1645920"/>
-            <a:ext cx="2468880" cy="4389120"/>
+            <a:off x="731520" y="1371600"/>
+            <a:ext cx="10698480" cy="4937760"/>
           </a:xfrm>
-          <a:prstGeom prst="roundRect">
+          <a:prstGeom prst="rect">
             <a:avLst/>
           </a:prstGeom>
-          <a:solidFill>
-            <a:srgbClr val="1E293B"/>
-          </a:solidFill>
-          <a:ln w="19050">
-            <a:solidFill>
-              <a:srgbClr val="334155"/>
-            </a:solidFill>
-          </a:ln>
         </p:spPr>
-        <p:style>
-          <a:lnRef idx="1">
-            <a:schemeClr val="accent1"/>
-          </a:lnRef>
-          <a:fillRef idx="3">
-            <a:schemeClr val="accent1"/>
-          </a:fillRef>
-          <a:effectRef idx="2">
-            <a:schemeClr val="accent1"/>
-          </a:effectRef>
-          <a:fontRef idx="minor">
-            <a:schemeClr val="lt1"/>
-          </a:fontRef>
-        </p:style>
-        <p:txBody>
-          <a:bodyPr rtlCol="0" anchor="ctr" wrap="square"/>
-          <a:lstStyle/>
-          <a:p>
-            <a:pPr algn="ctr">
-              <a:defRPr b="1" sz="1400">
-                <a:solidFill>
-                  <a:srgbClr val="3B82F6"/>
-                </a:solidFill>
-              </a:defRPr>
-            </a:pPr>
-            <a:r>
-              <a:t>DRIVING ADAPTERS (Inputs)</a:t>
-            </a:r>
-          </a:p>
-          <a:p>
-            <a:br/>
-            <a:pPr>
-              <a:defRPr sz="1300">
-                <a:solidFill>
-                  <a:srgbClr val="F8FAFC"/>
-                </a:solidFill>
-              </a:defRPr>
-            </a:pPr>
-            <a:r>
-              <a:t>Foot Gas Pedal</a:t>
-            </a:r>
-            <a:br/>
-            <a:r>
-              <a:t>Cruise Control Button</a:t>
-            </a:r>
-            <a:br/>
-            <a:r>
-              <a:t>Mobile App Remote</a:t>
-            </a:r>
-          </a:p>
-        </p:txBody>
-      </p:sp>
-      <p:sp>
-        <p:nvSpPr>
-          <p:cNvPr id="4" name="Rounded Rectangle 3"/>
-          <p:cNvSpPr/>
-          <p:nvPr/>
-        </p:nvSpPr>
-        <p:spPr>
-          <a:xfrm>
-            <a:off x="3566160" y="1645920"/>
-            <a:ext cx="2468880" cy="4389120"/>
-          </a:xfrm>
-          <a:prstGeom prst="roundRect">
-            <a:avLst/>
-          </a:prstGeom>
-          <a:solidFill>
-            <a:srgbClr val="1E293B"/>
-          </a:solidFill>
-          <a:ln w="19050">
-            <a:solidFill>
-              <a:srgbClr val="334155"/>
-            </a:solidFill>
-          </a:ln>
-        </p:spPr>
-        <p:style>
-          <a:lnRef idx="1">
-            <a:schemeClr val="accent1"/>
-          </a:lnRef>
-          <a:fillRef idx="3">
-            <a:schemeClr val="accent1"/>
-          </a:fillRef>
-          <a:effectRef idx="2">
-            <a:schemeClr val="accent1"/>
-          </a:effectRef>
-          <a:fontRef idx="minor">
-            <a:schemeClr val="lt1"/>
-          </a:fontRef>
-        </p:style>
-        <p:txBody>
-          <a:bodyPr rtlCol="0" anchor="ctr" wrap="square"/>
-          <a:lstStyle/>
-          <a:p>
-            <a:pPr algn="ctr">
-              <a:defRPr b="1" sz="1400">
-                <a:solidFill>
-                  <a:srgbClr val="F59E0B"/>
-                </a:solidFill>
-              </a:defRPr>
-            </a:pPr>
-            <a:r>
-              <a:t>INPUT PORTS</a:t>
-            </a:r>
-          </a:p>
-          <a:p>
-            <a:br/>
-            <a:pPr>
-              <a:defRPr sz="1300">
-                <a:solidFill>
-                  <a:srgbClr val="F8FAFC"/>
-                </a:solidFill>
-              </a:defRPr>
-            </a:pPr>
-            <a:r>
-              <a:t>Throttle Socket Interface</a:t>
-            </a:r>
-            <a:br/>
-            <a:r>
-              <a:t>(Standard Contract)</a:t>
-            </a:r>
-          </a:p>
-        </p:txBody>
-      </p:sp>
-      <p:sp>
-        <p:nvSpPr>
-          <p:cNvPr id="5" name="Rounded Rectangle 4"/>
-          <p:cNvSpPr/>
-          <p:nvPr/>
-        </p:nvSpPr>
-        <p:spPr>
-          <a:xfrm>
-            <a:off x="6217920" y="1645920"/>
-            <a:ext cx="2468880" cy="4389120"/>
-          </a:xfrm>
-          <a:prstGeom prst="roundRect">
-            <a:avLst/>
-          </a:prstGeom>
-          <a:solidFill>
-            <a:srgbClr val="1E293B"/>
-          </a:solidFill>
-          <a:ln w="19050">
-            <a:solidFill>
-              <a:srgbClr val="334155"/>
-            </a:solidFill>
-          </a:ln>
-        </p:spPr>
-        <p:style>
-          <a:lnRef idx="1">
-            <a:schemeClr val="accent1"/>
-          </a:lnRef>
-          <a:fillRef idx="3">
-            <a:schemeClr val="accent1"/>
-          </a:fillRef>
-          <a:effectRef idx="2">
-            <a:schemeClr val="accent1"/>
-          </a:effectRef>
-          <a:fontRef idx="minor">
-            <a:schemeClr val="lt1"/>
-          </a:fontRef>
-        </p:style>
-        <p:txBody>
-          <a:bodyPr rtlCol="0" anchor="ctr" wrap="square"/>
-          <a:lstStyle/>
-          <a:p>
-            <a:pPr algn="ctr">
-              <a:defRPr b="1" sz="1400">
-                <a:solidFill>
-                  <a:srgbClr val="10B981"/>
-                </a:solidFill>
-              </a:defRPr>
-            </a:pPr>
-            <a:r>
-              <a:t>CORE ENGINE (Hexagon)</a:t>
-            </a:r>
-          </a:p>
-          <a:p>
-            <a:br/>
-            <a:pPr>
-              <a:defRPr sz="1300">
-                <a:solidFill>
-                  <a:srgbClr val="F8FAFC"/>
-                </a:solidFill>
-              </a:defRPr>
-            </a:pPr>
-            <a:r>
-              <a:t>Engine Cylinder &amp;</a:t>
-            </a:r>
-            <a:br/>
-            <a:r>
-              <a:t>Combustion Rules</a:t>
-            </a:r>
-            <a:br/>
-            <a:r>
-              <a:t>(Independent Core)</a:t>
-            </a:r>
-          </a:p>
-        </p:txBody>
-      </p:sp>
-      <p:sp>
-        <p:nvSpPr>
-          <p:cNvPr id="6" name="Rounded Rectangle 5"/>
-          <p:cNvSpPr/>
-          <p:nvPr/>
-        </p:nvSpPr>
-        <p:spPr>
-          <a:xfrm>
-            <a:off x="8961120" y="1645920"/>
-            <a:ext cx="2468880" cy="4389120"/>
-          </a:xfrm>
-          <a:prstGeom prst="roundRect">
-            <a:avLst/>
-          </a:prstGeom>
-          <a:solidFill>
-            <a:srgbClr val="1E293B"/>
-          </a:solidFill>
-          <a:ln w="19050">
-            <a:solidFill>
-              <a:srgbClr val="334155"/>
-            </a:solidFill>
-          </a:ln>
-        </p:spPr>
-        <p:style>
-          <a:lnRef idx="1">
-            <a:schemeClr val="accent1"/>
-          </a:lnRef>
-          <a:fillRef idx="3">
-            <a:schemeClr val="accent1"/>
-          </a:fillRef>
-          <a:effectRef idx="2">
-            <a:schemeClr val="accent1"/>
-          </a:effectRef>
-          <a:fontRef idx="minor">
-            <a:schemeClr val="lt1"/>
-          </a:fontRef>
-        </p:style>
-        <p:txBody>
-          <a:bodyPr rtlCol="0" anchor="ctr" wrap="square"/>
-          <a:lstStyle/>
-          <a:p>
-            <a:pPr algn="ctr">
-              <a:defRPr b="1" sz="1400">
-                <a:solidFill>
-                  <a:srgbClr val="3B82F6"/>
-                </a:solidFill>
-              </a:defRPr>
-            </a:pPr>
-            <a:r>
-              <a:t>OUTPUT PORTS &amp; ADAPTERS</a:t>
-            </a:r>
-          </a:p>
-          <a:p>
-            <a:br/>
-            <a:pPr>
-              <a:defRPr sz="1300">
-                <a:solidFill>
-                  <a:srgbClr val="F8FAFC"/>
-                </a:solidFill>
-              </a:defRPr>
-            </a:pPr>
-            <a:r>
-              <a:t>Fuel Port -&gt; Petrol Tank / Battery</a:t>
-            </a:r>
-            <a:br/>
-            <a:r>
-              <a:t>Drivetrain Port -&gt; Wheels</a:t>
-            </a:r>
-          </a:p>
-        </p:txBody>
-      </p:sp>
+      </p:pic>
     </p:spTree>
   </p:cSld>
   <p:clrMapOvr>
@@ -4741,7 +4143,7 @@
               </a:defRPr>
             </a:pPr>
             <a:r>
-              <a:t>CODEBASE MAPPING</a:t>
+              <a:t>APPLICATION INFRASTRUCTURE MAPPING</a:t>
             </a:r>
           </a:p>
           <a:p>
@@ -4759,274 +4161,30 @@
           </a:p>
         </p:txBody>
       </p:sp>
-      <p:sp>
-        <p:nvSpPr>
-          <p:cNvPr id="3" name="Rounded Rectangle 2"/>
-          <p:cNvSpPr/>
+      <p:pic>
+        <p:nvPicPr>
+          <p:cNvPr id="3" name="Picture 2" descr="diagram_satellite_hex.png"/>
+          <p:cNvPicPr>
+            <a:picLocks noChangeAspect="1"/>
+          </p:cNvPicPr>
           <p:nvPr/>
-        </p:nvSpPr>
+        </p:nvPicPr>
+        <p:blipFill>
+          <a:blip r:embed="rId2"/>
+          <a:stretch>
+            <a:fillRect/>
+          </a:stretch>
+        </p:blipFill>
         <p:spPr>
           <a:xfrm>
-            <a:off x="731520" y="1645920"/>
-            <a:ext cx="2468880" cy="4389120"/>
+            <a:off x="731520" y="1371600"/>
+            <a:ext cx="10698480" cy="4937760"/>
           </a:xfrm>
-          <a:prstGeom prst="roundRect">
+          <a:prstGeom prst="rect">
             <a:avLst/>
           </a:prstGeom>
-          <a:solidFill>
-            <a:srgbClr val="1E293B"/>
-          </a:solidFill>
-          <a:ln w="19050">
-            <a:solidFill>
-              <a:srgbClr val="334155"/>
-            </a:solidFill>
-          </a:ln>
         </p:spPr>
-        <p:style>
-          <a:lnRef idx="1">
-            <a:schemeClr val="accent1"/>
-          </a:lnRef>
-          <a:fillRef idx="3">
-            <a:schemeClr val="accent1"/>
-          </a:fillRef>
-          <a:effectRef idx="2">
-            <a:schemeClr val="accent1"/>
-          </a:effectRef>
-          <a:fontRef idx="minor">
-            <a:schemeClr val="lt1"/>
-          </a:fontRef>
-        </p:style>
-        <p:txBody>
-          <a:bodyPr rtlCol="0" anchor="ctr" wrap="square"/>
-          <a:lstStyle/>
-          <a:p>
-            <a:pPr algn="ctr">
-              <a:defRPr b="1" sz="1400">
-                <a:solidFill>
-                  <a:srgbClr val="10B981"/>
-                </a:solidFill>
-              </a:defRPr>
-            </a:pPr>
-            <a:r>
-              <a:t>1. Driving Adapters (REST)</a:t>
-            </a:r>
-          </a:p>
-          <a:p>
-            <a:br/>
-            <a:pPr>
-              <a:defRPr sz="1300">
-                <a:solidFill>
-                  <a:srgbClr val="F8FAFC"/>
-                </a:solidFill>
-              </a:defRPr>
-            </a:pPr>
-            <a:r>
-              <a:t>SatelliteController parses HTTP JSON -&gt; calls Inbound Port interface.</a:t>
-            </a:r>
-          </a:p>
-        </p:txBody>
-      </p:sp>
-      <p:sp>
-        <p:nvSpPr>
-          <p:cNvPr id="4" name="Rounded Rectangle 3"/>
-          <p:cNvSpPr/>
-          <p:nvPr/>
-        </p:nvSpPr>
-        <p:spPr>
-          <a:xfrm>
-            <a:off x="3566160" y="1645920"/>
-            <a:ext cx="2468880" cy="4389120"/>
-          </a:xfrm>
-          <a:prstGeom prst="roundRect">
-            <a:avLst/>
-          </a:prstGeom>
-          <a:solidFill>
-            <a:srgbClr val="1E293B"/>
-          </a:solidFill>
-          <a:ln w="19050">
-            <a:solidFill>
-              <a:srgbClr val="334155"/>
-            </a:solidFill>
-          </a:ln>
-        </p:spPr>
-        <p:style>
-          <a:lnRef idx="1">
-            <a:schemeClr val="accent1"/>
-          </a:lnRef>
-          <a:fillRef idx="3">
-            <a:schemeClr val="accent1"/>
-          </a:fillRef>
-          <a:effectRef idx="2">
-            <a:schemeClr val="accent1"/>
-          </a:effectRef>
-          <a:fontRef idx="minor">
-            <a:schemeClr val="lt1"/>
-          </a:fontRef>
-        </p:style>
-        <p:txBody>
-          <a:bodyPr rtlCol="0" anchor="ctr" wrap="square"/>
-          <a:lstStyle/>
-          <a:p>
-            <a:pPr algn="ctr">
-              <a:defRPr b="1" sz="1400">
-                <a:solidFill>
-                  <a:srgbClr val="10B981"/>
-                </a:solidFill>
-              </a:defRPr>
-            </a:pPr>
-            <a:r>
-              <a:t>2. Inbound Ports (Domain)</a:t>
-            </a:r>
-          </a:p>
-          <a:p>
-            <a:br/>
-            <a:pPr>
-              <a:defRPr sz="1300">
-                <a:solidFill>
-                  <a:srgbClr val="F8FAFC"/>
-                </a:solidFill>
-              </a:defRPr>
-            </a:pPr>
-            <a:r>
-              <a:t>LaunchSatelliteUseCase &amp; UpdateTelemetryUseCase interfaces defined in domain.</a:t>
-            </a:r>
-          </a:p>
-        </p:txBody>
-      </p:sp>
-      <p:sp>
-        <p:nvSpPr>
-          <p:cNvPr id="5" name="Rounded Rectangle 4"/>
-          <p:cNvSpPr/>
-          <p:nvPr/>
-        </p:nvSpPr>
-        <p:spPr>
-          <a:xfrm>
-            <a:off x="6217920" y="1645920"/>
-            <a:ext cx="2468880" cy="4389120"/>
-          </a:xfrm>
-          <a:prstGeom prst="roundRect">
-            <a:avLst/>
-          </a:prstGeom>
-          <a:solidFill>
-            <a:srgbClr val="1E293B"/>
-          </a:solidFill>
-          <a:ln w="19050">
-            <a:solidFill>
-              <a:srgbClr val="334155"/>
-            </a:solidFill>
-          </a:ln>
-        </p:spPr>
-        <p:style>
-          <a:lnRef idx="1">
-            <a:schemeClr val="accent1"/>
-          </a:lnRef>
-          <a:fillRef idx="3">
-            <a:schemeClr val="accent1"/>
-          </a:fillRef>
-          <a:effectRef idx="2">
-            <a:schemeClr val="accent1"/>
-          </a:effectRef>
-          <a:fontRef idx="minor">
-            <a:schemeClr val="lt1"/>
-          </a:fontRef>
-        </p:style>
-        <p:txBody>
-          <a:bodyPr rtlCol="0" anchor="ctr" wrap="square"/>
-          <a:lstStyle/>
-          <a:p>
-            <a:pPr algn="ctr">
-              <a:defRPr b="1" sz="1400">
-                <a:solidFill>
-                  <a:srgbClr val="10B981"/>
-                </a:solidFill>
-              </a:defRPr>
-            </a:pPr>
-            <a:r>
-              <a:t>3. Outbound Ports (Domain)</a:t>
-            </a:r>
-          </a:p>
-          <a:p>
-            <a:br/>
-            <a:pPr>
-              <a:defRPr sz="1300">
-                <a:solidFill>
-                  <a:srgbClr val="F8FAFC"/>
-                </a:solidFill>
-              </a:defRPr>
-            </a:pPr>
-            <a:r>
-              <a:t>SatelliteRepository interface defined in domain using domain types.</a:t>
-            </a:r>
-          </a:p>
-        </p:txBody>
-      </p:sp>
-      <p:sp>
-        <p:nvSpPr>
-          <p:cNvPr id="6" name="Rounded Rectangle 5"/>
-          <p:cNvSpPr/>
-          <p:nvPr/>
-        </p:nvSpPr>
-        <p:spPr>
-          <a:xfrm>
-            <a:off x="8961120" y="1645920"/>
-            <a:ext cx="2468880" cy="4389120"/>
-          </a:xfrm>
-          <a:prstGeom prst="roundRect">
-            <a:avLst/>
-          </a:prstGeom>
-          <a:solidFill>
-            <a:srgbClr val="1E293B"/>
-          </a:solidFill>
-          <a:ln w="19050">
-            <a:solidFill>
-              <a:srgbClr val="334155"/>
-            </a:solidFill>
-          </a:ln>
-        </p:spPr>
-        <p:style>
-          <a:lnRef idx="1">
-            <a:schemeClr val="accent1"/>
-          </a:lnRef>
-          <a:fillRef idx="3">
-            <a:schemeClr val="accent1"/>
-          </a:fillRef>
-          <a:effectRef idx="2">
-            <a:schemeClr val="accent1"/>
-          </a:effectRef>
-          <a:fontRef idx="minor">
-            <a:schemeClr val="lt1"/>
-          </a:fontRef>
-        </p:style>
-        <p:txBody>
-          <a:bodyPr rtlCol="0" anchor="ctr" wrap="square"/>
-          <a:lstStyle/>
-          <a:p>
-            <a:pPr algn="ctr">
-              <a:defRPr b="1" sz="1400">
-                <a:solidFill>
-                  <a:srgbClr val="10B981"/>
-                </a:solidFill>
-              </a:defRPr>
-            </a:pPr>
-            <a:r>
-              <a:t>4. Driven Adapters (JPA)</a:t>
-            </a:r>
-          </a:p>
-          <a:p>
-            <a:br/>
-            <a:pPr>
-              <a:defRPr sz="1300">
-                <a:solidFill>
-                  <a:srgbClr val="F8FAFC"/>
-                </a:solidFill>
-              </a:defRPr>
-            </a:pPr>
-            <a:r>
-              <a:t>SatelliteJpaAdapter implements SatelliteRepository &amp; converts to SatelliteJpaEntity.</a:t>
-            </a:r>
-          </a:p>
-        </p:txBody>
-      </p:sp>
+      </p:pic>
     </p:spTree>
   </p:cSld>
   <p:clrMapOvr>

</xml_diff>

<commit_message>
docs: add HD diagram for Multi-Database Adapter Swapping Demo and update PPTX + README
</commit_message>
<xml_diff>
--- a/Satellite_Architecture_DDD_Hexagonal_ArchUnit.pptx
+++ b/Satellite_Architecture_DDD_Hexagonal_ArchUnit.pptx
@@ -12,9 +12,6 @@
     <p:sldId id="260" r:id="rId11"/>
     <p:sldId id="261" r:id="rId12"/>
     <p:sldId id="262" r:id="rId13"/>
-    <p:sldId id="263" r:id="rId14"/>
-    <p:sldId id="264" r:id="rId15"/>
-    <p:sldId id="265" r:id="rId16"/>
   </p:sldIdLst>
   <p:sldSz cx="12191695" cy="6858000" type="screen4x3"/>
   <p:notesSz cx="6858000" cy="9144000"/>
@@ -3113,8 +3110,8 @@
         </p:nvSpPr>
         <p:spPr>
           <a:xfrm>
-            <a:off x="914400" y="1645920"/>
-            <a:ext cx="10332720" cy="3200400"/>
+            <a:off x="914400" y="2011680"/>
+            <a:ext cx="10332720" cy="2743200"/>
           </a:xfrm>
           <a:prstGeom prst="rect">
             <a:avLst/>
@@ -3132,7 +3129,6 @@
                 <a:solidFill>
                   <a:srgbClr val="3B82F6"/>
                 </a:solidFill>
-                <a:latin typeface="Arial"/>
               </a:defRPr>
             </a:pPr>
             <a:r>
@@ -3145,422 +3141,22 @@
                 <a:solidFill>
                   <a:srgbClr val="F8FAFC"/>
                 </a:solidFill>
-                <a:latin typeface="Arial"/>
               </a:defRPr>
             </a:pPr>
             <a:r>
-              <a:t>Mastering Enterprise Java Architecture</a:t>
+              <a:t>DDD + Hexagonal Architecture + ArchUnit</a:t>
             </a:r>
           </a:p>
           <a:p>
             <a:pPr>
-              <a:defRPr sz="2000">
-                <a:solidFill>
-                  <a:srgbClr val="F59E0B"/>
-                </a:solidFill>
-                <a:latin typeface="Arial"/>
+              <a:defRPr sz="1800">
+                <a:solidFill>
+                  <a:srgbClr val="94A3B8"/>
+                </a:solidFill>
               </a:defRPr>
             </a:pPr>
             <a:r>
-              <a:t>Domain-Driven Design (DDD)  |  Hexagonal Architecture  |  ArchUnit</a:t>
-            </a:r>
-          </a:p>
-          <a:p>
-            <a:br/>
-            <a:pPr>
-              <a:defRPr sz="1400">
-                <a:solidFill>
-                  <a:srgbClr val="94A3B8"/>
-                </a:solidFill>
-                <a:latin typeface="Arial"/>
-              </a:defRPr>
-            </a:pPr>
-            <a:r>
-              <a:t>A Production-Grade Spring Boot Reference Project with Executable Architecture Controls</a:t>
-            </a:r>
-          </a:p>
-        </p:txBody>
-      </p:sp>
-      <p:sp>
-        <p:nvSpPr>
-          <p:cNvPr id="3" name="Rounded Rectangle 2"/>
-          <p:cNvSpPr/>
-          <p:nvPr/>
-        </p:nvSpPr>
-        <p:spPr>
-          <a:xfrm>
-            <a:off x="914400" y="4846320"/>
-            <a:ext cx="3291840" cy="1280160"/>
-          </a:xfrm>
-          <a:prstGeom prst="roundRect">
-            <a:avLst/>
-          </a:prstGeom>
-          <a:solidFill>
-            <a:srgbClr val="1E293B"/>
-          </a:solidFill>
-          <a:ln w="19050">
-            <a:solidFill>
-              <a:srgbClr val="334155"/>
-            </a:solidFill>
-          </a:ln>
-        </p:spPr>
-        <p:style>
-          <a:lnRef idx="1">
-            <a:schemeClr val="accent1"/>
-          </a:lnRef>
-          <a:fillRef idx="3">
-            <a:schemeClr val="accent1"/>
-          </a:fillRef>
-          <a:effectRef idx="2">
-            <a:schemeClr val="accent1"/>
-          </a:effectRef>
-          <a:fontRef idx="minor">
-            <a:schemeClr val="lt1"/>
-          </a:fontRef>
-        </p:style>
-        <p:txBody>
-          <a:bodyPr rtlCol="0" anchor="ctr" wrap="square"/>
-          <a:lstStyle/>
-          <a:p>
-            <a:pPr algn="ctr">
-              <a:defRPr b="1" sz="1600">
-                <a:solidFill>
-                  <a:srgbClr val="F8FAFC"/>
-                </a:solidFill>
-              </a:defRPr>
-            </a:pPr>
-            <a:r>
-              <a:t>1. DDD Core</a:t>
-            </a:r>
-          </a:p>
-          <a:p>
-            <a:pPr>
-              <a:defRPr sz="1200">
-                <a:solidFill>
-                  <a:srgbClr val="94A3B8"/>
-                </a:solidFill>
-              </a:defRPr>
-            </a:pPr>
-            <a:r>
-              <a:t>Rich Aggregates &amp; Value Objects with pure Java business invariants.</a:t>
-            </a:r>
-          </a:p>
-        </p:txBody>
-      </p:sp>
-      <p:sp>
-        <p:nvSpPr>
-          <p:cNvPr id="4" name="Rounded Rectangle 3"/>
-          <p:cNvSpPr/>
-          <p:nvPr/>
-        </p:nvSpPr>
-        <p:spPr>
-          <a:xfrm>
-            <a:off x="4434840" y="4846320"/>
-            <a:ext cx="3291840" cy="1280160"/>
-          </a:xfrm>
-          <a:prstGeom prst="roundRect">
-            <a:avLst/>
-          </a:prstGeom>
-          <a:solidFill>
-            <a:srgbClr val="1E293B"/>
-          </a:solidFill>
-          <a:ln w="19050">
-            <a:solidFill>
-              <a:srgbClr val="334155"/>
-            </a:solidFill>
-          </a:ln>
-        </p:spPr>
-        <p:style>
-          <a:lnRef idx="1">
-            <a:schemeClr val="accent1"/>
-          </a:lnRef>
-          <a:fillRef idx="3">
-            <a:schemeClr val="accent1"/>
-          </a:fillRef>
-          <a:effectRef idx="2">
-            <a:schemeClr val="accent1"/>
-          </a:effectRef>
-          <a:fontRef idx="minor">
-            <a:schemeClr val="lt1"/>
-          </a:fontRef>
-        </p:style>
-        <p:txBody>
-          <a:bodyPr rtlCol="0" anchor="ctr" wrap="square"/>
-          <a:lstStyle/>
-          <a:p>
-            <a:pPr algn="ctr">
-              <a:defRPr b="1" sz="1600">
-                <a:solidFill>
-                  <a:srgbClr val="F8FAFC"/>
-                </a:solidFill>
-              </a:defRPr>
-            </a:pPr>
-            <a:r>
-              <a:t>2. Hexagonal Architecture</a:t>
-            </a:r>
-          </a:p>
-          <a:p>
-            <a:pPr>
-              <a:defRPr sz="1200">
-                <a:solidFill>
-                  <a:srgbClr val="94A3B8"/>
-                </a:solidFill>
-              </a:defRPr>
-            </a:pPr>
-            <a:r>
-              <a:t>Inward Ports &amp; Adapters isolating business logic from HTTP &amp; JPA.</a:t>
-            </a:r>
-          </a:p>
-        </p:txBody>
-      </p:sp>
-      <p:sp>
-        <p:nvSpPr>
-          <p:cNvPr id="5" name="Rounded Rectangle 4"/>
-          <p:cNvSpPr/>
-          <p:nvPr/>
-        </p:nvSpPr>
-        <p:spPr>
-          <a:xfrm>
-            <a:off x="7955279" y="4846320"/>
-            <a:ext cx="3291840" cy="1280160"/>
-          </a:xfrm>
-          <a:prstGeom prst="roundRect">
-            <a:avLst/>
-          </a:prstGeom>
-          <a:solidFill>
-            <a:srgbClr val="1E293B"/>
-          </a:solidFill>
-          <a:ln w="19050">
-            <a:solidFill>
-              <a:srgbClr val="334155"/>
-            </a:solidFill>
-          </a:ln>
-        </p:spPr>
-        <p:style>
-          <a:lnRef idx="1">
-            <a:schemeClr val="accent1"/>
-          </a:lnRef>
-          <a:fillRef idx="3">
-            <a:schemeClr val="accent1"/>
-          </a:fillRef>
-          <a:effectRef idx="2">
-            <a:schemeClr val="accent1"/>
-          </a:effectRef>
-          <a:fontRef idx="minor">
-            <a:schemeClr val="lt1"/>
-          </a:fontRef>
-        </p:style>
-        <p:txBody>
-          <a:bodyPr rtlCol="0" anchor="ctr" wrap="square"/>
-          <a:lstStyle/>
-          <a:p>
-            <a:pPr algn="ctr">
-              <a:defRPr b="1" sz="1600">
-                <a:solidFill>
-                  <a:srgbClr val="F8FAFC"/>
-                </a:solidFill>
-              </a:defRPr>
-            </a:pPr>
-            <a:r>
-              <a:t>3. ArchUnit Guardrails</a:t>
-            </a:r>
-          </a:p>
-          <a:p>
-            <a:pPr>
-              <a:defRPr sz="1200">
-                <a:solidFill>
-                  <a:srgbClr val="94A3B8"/>
-                </a:solidFill>
-              </a:defRPr>
-            </a:pPr>
-            <a:r>
-              <a:t>Automated JUnit 5 tests failing the build if rules are violated.</a:t>
-            </a:r>
-          </a:p>
-        </p:txBody>
-      </p:sp>
-    </p:spTree>
-  </p:cSld>
-  <p:clrMapOvr>
-    <a:masterClrMapping/>
-  </p:clrMapOvr>
-</p:sld>
-</file>
-
-<file path=ppt/slides/slide10.xml><?xml version="1.0" encoding="utf-8"?>
-<p:sld xmlns:a="http://schemas.openxmlformats.org/drawingml/2006/main" xmlns:p="http://schemas.openxmlformats.org/presentationml/2006/main" xmlns:r="http://schemas.openxmlformats.org/officeDocument/2006/relationships">
-  <p:cSld>
-    <p:bg>
-      <p:bgPr>
-        <a:solidFill>
-          <a:srgbClr val="0F172A"/>
-        </a:solidFill>
-        <a:effectLst/>
-      </p:bgPr>
-    </p:bg>
-    <p:spTree>
-      <p:nvGrpSpPr>
-        <p:cNvPr id="1" name=""/>
-        <p:cNvGrpSpPr/>
-        <p:nvPr/>
-      </p:nvGrpSpPr>
-      <p:grpSpPr/>
-      <p:sp>
-        <p:nvSpPr>
-          <p:cNvPr id="2" name="TextBox 1"/>
-          <p:cNvSpPr txBox="1"/>
-          <p:nvPr/>
-        </p:nvSpPr>
-        <p:spPr>
-          <a:xfrm>
-            <a:off x="731520" y="365760"/>
-            <a:ext cx="10698480" cy="822960"/>
-          </a:xfrm>
-          <a:prstGeom prst="rect">
-            <a:avLst/>
-          </a:prstGeom>
-          <a:noFill/>
-        </p:spPr>
-        <p:txBody>
-          <a:bodyPr wrap="square" lIns="0" tIns="0" rIns="0" bIns="0">
-            <a:spAutoFit/>
-          </a:bodyPr>
-          <a:lstStyle/>
-          <a:p>
-            <a:pPr>
-              <a:defRPr sz="1100" b="1">
-                <a:solidFill>
-                  <a:srgbClr val="3B82F6"/>
-                </a:solidFill>
-                <a:latin typeface="Arial"/>
-              </a:defRPr>
-            </a:pPr>
-            <a:r>
-              <a:t>SUMMARY &amp; Q&amp;A</a:t>
-            </a:r>
-          </a:p>
-          <a:p>
-            <a:pPr>
-              <a:defRPr sz="2400" b="1">
-                <a:solidFill>
-                  <a:srgbClr val="F8FAFC"/>
-                </a:solidFill>
-                <a:latin typeface="Arial"/>
-              </a:defRPr>
-            </a:pPr>
-            <a:r>
-              <a:t>Conclusion &amp; GitHub Repository</a:t>
-            </a:r>
-          </a:p>
-        </p:txBody>
-      </p:sp>
-      <p:sp>
-        <p:nvSpPr>
-          <p:cNvPr id="3" name="Rounded Rectangle 2"/>
-          <p:cNvSpPr/>
-          <p:nvPr/>
-        </p:nvSpPr>
-        <p:spPr>
-          <a:xfrm>
-            <a:off x="1371600" y="1645920"/>
-            <a:ext cx="9418320" cy="4389120"/>
-          </a:xfrm>
-          <a:prstGeom prst="roundRect">
-            <a:avLst/>
-          </a:prstGeom>
-          <a:solidFill>
-            <a:srgbClr val="1E293B"/>
-          </a:solidFill>
-          <a:ln w="19050">
-            <a:solidFill>
-              <a:srgbClr val="334155"/>
-            </a:solidFill>
-          </a:ln>
-        </p:spPr>
-        <p:style>
-          <a:lnRef idx="1">
-            <a:schemeClr val="accent1"/>
-          </a:lnRef>
-          <a:fillRef idx="3">
-            <a:schemeClr val="accent1"/>
-          </a:fillRef>
-          <a:effectRef idx="2">
-            <a:schemeClr val="accent1"/>
-          </a:effectRef>
-          <a:fontRef idx="minor">
-            <a:schemeClr val="lt1"/>
-          </a:fontRef>
-        </p:style>
-        <p:txBody>
-          <a:bodyPr rtlCol="0" anchor="ctr" wrap="square"/>
-          <a:lstStyle/>
-          <a:p>
-            <a:pPr algn="ctr">
-              <a:defRPr b="1" sz="2000">
-                <a:solidFill>
-                  <a:srgbClr val="F59E0B"/>
-                </a:solidFill>
-              </a:defRPr>
-            </a:pPr>
-            <a:r>
-              <a:t>Project Summary &amp; Takeaways</a:t>
-            </a:r>
-          </a:p>
-          <a:p>
-            <a:pPr>
-              <a:defRPr sz="1400">
-                <a:solidFill>
-                  <a:srgbClr val="F8FAFC"/>
-                </a:solidFill>
-              </a:defRPr>
-            </a:pPr>
-            <a:r>
-              <a:t>• Domain-Driven Design keeps core business rules clean, testable, and rich.</a:t>
-            </a:r>
-          </a:p>
-          <a:p>
-            <a:pPr>
-              <a:defRPr sz="1400">
-                <a:solidFill>
-                  <a:srgbClr val="F8FAFC"/>
-                </a:solidFill>
-              </a:defRPr>
-            </a:pPr>
-            <a:r>
-              <a:t>• Hexagonal Architecture isolates business logic from Spring, JPA, and HTTP infrastructure.</a:t>
-            </a:r>
-          </a:p>
-          <a:p>
-            <a:pPr>
-              <a:defRPr sz="1400">
-                <a:solidFill>
-                  <a:srgbClr val="F8FAFC"/>
-                </a:solidFill>
-              </a:defRPr>
-            </a:pPr>
-            <a:r>
-              <a:t>• ArchUnit automates governance, acting as an unbypassable build gate in CI/CD pipelines.</a:t>
-            </a:r>
-          </a:p>
-          <a:p>
-            <a:pPr>
-              <a:defRPr sz="1400">
-                <a:solidFill>
-                  <a:srgbClr val="F8FAFC"/>
-                </a:solidFill>
-              </a:defRPr>
-            </a:pPr>
-          </a:p>
-          <a:p>
-            <a:pPr>
-              <a:defRPr sz="1400" b="1">
-                <a:solidFill>
-                  <a:srgbClr val="10B981"/>
-                </a:solidFill>
-              </a:defRPr>
-            </a:pPr>
-            <a:r>
-              <a:t>GitHub Repository: https://github.com/hykuBipin/DDD_HEXAGONAL_ARCHUNIT_NEW</a:t>
+              <a:t>Reference Architecture &amp; Live Demo Guide for Enterprise Java 21 Applications</a:t>
             </a:r>
           </a:p>
         </p:txBody>
@@ -3622,7 +3218,7 @@
               </a:defRPr>
             </a:pPr>
             <a:r>
-              <a:t>CHALLENGES IN TRADITIONAL ENTERPRISE JAVA</a:t>
+              <a:t>ARCHITECTURAL CONTEXT</a:t>
             </a:r>
           </a:p>
           <a:p>
@@ -3635,255 +3231,102 @@
               </a:defRPr>
             </a:pPr>
             <a:r>
-              <a:t>The Problem: Architectural Decay &amp; Framework Coupling</a:t>
-            </a:r>
-          </a:p>
-        </p:txBody>
-      </p:sp>
-      <p:sp>
-        <p:nvSpPr>
-          <p:cNvPr id="3" name="Rounded Rectangle 2"/>
-          <p:cNvSpPr/>
+              <a:t>Why Move Beyond Traditional 3-Tier Layered Java?</a:t>
+            </a:r>
+          </a:p>
+        </p:txBody>
+      </p:sp>
+      <p:sp>
+        <p:nvSpPr>
+          <p:cNvPr id="3" name="TextBox 2"/>
+          <p:cNvSpPr txBox="1"/>
           <p:nvPr/>
         </p:nvSpPr>
         <p:spPr>
           <a:xfrm>
             <a:off x="731520" y="1371600"/>
-            <a:ext cx="5120640" cy="4754880"/>
+            <a:ext cx="10698480" cy="4846320"/>
           </a:xfrm>
-          <a:prstGeom prst="roundRect">
+          <a:prstGeom prst="rect">
             <a:avLst/>
           </a:prstGeom>
-          <a:solidFill>
-            <a:srgbClr val="1E293B"/>
-          </a:solidFill>
-          <a:ln w="19050">
-            <a:solidFill>
-              <a:srgbClr val="334155"/>
-            </a:solidFill>
-          </a:ln>
+          <a:noFill/>
         </p:spPr>
-        <p:style>
-          <a:lnRef idx="1">
-            <a:schemeClr val="accent1"/>
-          </a:lnRef>
-          <a:fillRef idx="3">
-            <a:schemeClr val="accent1"/>
-          </a:fillRef>
-          <a:effectRef idx="2">
-            <a:schemeClr val="accent1"/>
-          </a:effectRef>
-          <a:fontRef idx="minor">
-            <a:schemeClr val="lt1"/>
-          </a:fontRef>
-        </p:style>
-        <p:txBody>
-          <a:bodyPr rtlCol="0" anchor="ctr" wrap="square"/>
-          <a:lstStyle/>
-          <a:p>
-            <a:pPr algn="ctr">
-              <a:defRPr b="1" sz="1800">
+        <p:txBody>
+          <a:bodyPr wrap="square">
+            <a:spAutoFit/>
+          </a:bodyPr>
+          <a:lstStyle/>
+          <a:p>
+            <a:pPr>
+              <a:defRPr b="1" sz="2000">
                 <a:solidFill>
                   <a:srgbClr val="F59E0B"/>
                 </a:solidFill>
               </a:defRPr>
             </a:pPr>
             <a:r>
-              <a:t>Traditional 3-Tier Pitfalls</a:t>
+              <a:t>Traditional 3-Tier Layered Architecture Problems:</a:t>
             </a:r>
           </a:p>
           <a:p>
             <a:pPr>
-              <a:defRPr b="1" sz="1400">
+              <a:defRPr sz="1600">
                 <a:solidFill>
                   <a:srgbClr val="F8FAFC"/>
                 </a:solidFill>
               </a:defRPr>
             </a:pPr>
             <a:r>
-              <a:t>• Anemic Domain Models: </a:t>
-            </a:r>
-            <a:r>
-              <a:rPr b="0">
-                <a:solidFill>
-                  <a:srgbClr val="94A3B8"/>
-                </a:solidFill>
-              </a:rPr>
-              <a:t>Entities are empty data shells (getters/setters). Business logic leaks into 2,000-line Spring @Services.</a:t>
+              <a:t>• Database-Centric Design: JPA @Entity classes contaminate business logic; schema changes break domain rules.</a:t>
             </a:r>
           </a:p>
           <a:p>
             <a:pPr>
-              <a:defRPr b="1" sz="1400">
+              <a:defRPr sz="1600">
                 <a:solidFill>
                   <a:srgbClr val="F8FAFC"/>
                 </a:solidFill>
               </a:defRPr>
             </a:pPr>
             <a:r>
-              <a:t>• Framework Lock-in: </a:t>
-            </a:r>
-            <a:r>
-              <a:rPr b="0">
-                <a:solidFill>
-                  <a:srgbClr val="94A3B8"/>
-                </a:solidFill>
-              </a:rPr>
-              <a:t>@Entity, @Table, and Jackson annotations blur domain boundaries with database and HTTP concerns.</a:t>
+              <a:t>• Framework Tight Coupling: @Service, @Autowired, and Jackson annotations scattered throughout business logic.</a:t>
             </a:r>
           </a:p>
           <a:p>
             <a:pPr>
-              <a:defRPr b="1" sz="1400">
+              <a:defRPr sz="1600">
                 <a:solidFill>
                   <a:srgbClr val="F8FAFC"/>
                 </a:solidFill>
               </a:defRPr>
             </a:pPr>
             <a:r>
-              <a:t>• Architectural Drift: </a:t>
-            </a:r>
-            <a:r>
-              <a:rPr b="0">
-                <a:solidFill>
-                  <a:srgbClr val="94A3B8"/>
-                </a:solidFill>
-              </a:rPr>
-              <a:t>Over time, Controllers bypass Services to call DAOs, creating cyclic dependencies and untestable code.</a:t>
+              <a:t>• Anemic Domain Models: Dumb POJOs with getters/setters; business logic trapped inside procedural services.</a:t>
             </a:r>
           </a:p>
           <a:p>
             <a:pPr>
-              <a:defRPr b="1" sz="1400">
+              <a:defRPr sz="1600">
                 <a:solidFill>
                   <a:srgbClr val="F8FAFC"/>
                 </a:solidFill>
               </a:defRPr>
             </a:pPr>
             <a:r>
-              <a:t>• Manual Reviews Don't Scale: </a:t>
-            </a:r>
-            <a:r>
-              <a:rPr b="0">
-                <a:solidFill>
-                  <a:srgbClr val="94A3B8"/>
-                </a:solidFill>
-              </a:rPr>
-              <a:t>PR code reviews miss subtle architecture violations under tight deadline pressure.</a:t>
-            </a:r>
-          </a:p>
-        </p:txBody>
-      </p:sp>
-      <p:sp>
-        <p:nvSpPr>
-          <p:cNvPr id="4" name="Rounded Rectangle 3"/>
-          <p:cNvSpPr/>
-          <p:nvPr/>
-        </p:nvSpPr>
-        <p:spPr>
-          <a:xfrm>
-            <a:off x="6217920" y="1371600"/>
-            <a:ext cx="5212080" cy="4754880"/>
-          </a:xfrm>
-          <a:prstGeom prst="roundRect">
-            <a:avLst/>
-          </a:prstGeom>
-          <a:solidFill>
-            <a:srgbClr val="1E293B"/>
-          </a:solidFill>
-          <a:ln w="19050">
-            <a:solidFill>
-              <a:srgbClr val="334155"/>
-            </a:solidFill>
-          </a:ln>
-        </p:spPr>
-        <p:style>
-          <a:lnRef idx="1">
-            <a:schemeClr val="accent1"/>
-          </a:lnRef>
-          <a:fillRef idx="3">
-            <a:schemeClr val="accent1"/>
-          </a:fillRef>
-          <a:effectRef idx="2">
-            <a:schemeClr val="accent1"/>
-          </a:effectRef>
-          <a:fontRef idx="minor">
-            <a:schemeClr val="lt1"/>
-          </a:fontRef>
-        </p:style>
-        <p:txBody>
-          <a:bodyPr rtlCol="0" anchor="ctr" wrap="square"/>
-          <a:lstStyle/>
-          <a:p>
-            <a:pPr algn="ctr">
-              <a:defRPr b="1" sz="1800">
-                <a:solidFill>
-                  <a:srgbClr val="EF4444"/>
+              <a:t>• Slow Test Feedback: Unit tests require booting Spring Context or mocking complex database repositories.</a:t>
+            </a:r>
+          </a:p>
+          <a:p>
+            <a:pPr>
+              <a:defRPr sz="1600">
+                <a:solidFill>
+                  <a:srgbClr val="F8FAFC"/>
                 </a:solidFill>
               </a:defRPr>
             </a:pPr>
             <a:r>
-              <a:t>Impact on Delivery &amp; Quality</a:t>
-            </a:r>
-          </a:p>
-          <a:p>
-            <a:pPr>
-              <a:defRPr b="1" sz="1400">
-                <a:solidFill>
-                  <a:srgbClr val="F8FAFC"/>
-                </a:solidFill>
-              </a:defRPr>
-            </a:pPr>
-            <a:r>
-              <a:t>✖ Slow Unit Testing: </a:t>
-            </a:r>
-            <a:r>
-              <a:rPr b="0">
-                <a:solidFill>
-                  <a:srgbClr val="94A3B8"/>
-                </a:solidFill>
-              </a:rPr>
-              <a:t>Cannot test core rules without booting full Spring context &amp; DB.</a:t>
-            </a:r>
-          </a:p>
-          <a:p>
-            <a:pPr>
-              <a:defRPr b="1" sz="1400">
-                <a:solidFill>
-                  <a:srgbClr val="F8FAFC"/>
-                </a:solidFill>
-              </a:defRPr>
-            </a:pPr>
-            <a:r>
-              <a:t>✖ Risk of Upgrades: </a:t>
-            </a:r>
-            <a:r>
-              <a:rPr b="0">
-                <a:solidFill>
-                  <a:srgbClr val="94A3B8"/>
-                </a:solidFill>
-              </a:rPr>
-              <a:t>Upgrading Spring or changing DB vendors breaks business logic.</a:t>
-            </a:r>
-          </a:p>
-          <a:p>
-            <a:pPr>
-              <a:defRPr b="1" sz="1400">
-                <a:solidFill>
-                  <a:srgbClr val="F8FAFC"/>
-                </a:solidFill>
-              </a:defRPr>
-            </a:pPr>
-            <a:r>
-              <a:t>✖ High Technical Debt: </a:t>
-            </a:r>
-            <a:r>
-              <a:rPr b="0">
-                <a:solidFill>
-                  <a:srgbClr val="94A3B8"/>
-                </a:solidFill>
-              </a:rPr>
-              <a:t>New developers struggle to know where business rules belong.</a:t>
+              <a:t>• Architectural Decay: Without automated guardrails, developers break layer boundaries over time.</a:t>
             </a:r>
           </a:p>
         </p:txBody>
@@ -3945,7 +3388,7 @@
               </a:defRPr>
             </a:pPr>
             <a:r>
-              <a:t>PURE BUSINESS LOGIC CORE</a:t>
+              <a:t>CORE CONCEPTS</a:t>
             </a:r>
           </a:p>
           <a:p>
@@ -3958,7 +3401,7 @@
               </a:defRPr>
             </a:pPr>
             <a:r>
-              <a:t>Pillar 1: Domain-Driven Design (DDD) Architecture</a:t>
+              <a:t>Domain-Driven Design (DDD) Core Architecture</a:t>
             </a:r>
           </a:p>
         </p:txBody>
@@ -3979,8 +3422,8 @@
         </p:blipFill>
         <p:spPr>
           <a:xfrm>
-            <a:off x="731520" y="1371600"/>
-            <a:ext cx="10698480" cy="4937760"/>
+            <a:off x="731520" y="1280160"/>
+            <a:ext cx="10698480" cy="6017895"/>
           </a:xfrm>
           <a:prstGeom prst="rect">
             <a:avLst/>
@@ -4044,7 +3487,7 @@
               </a:defRPr>
             </a:pPr>
             <a:r>
-              <a:t>PORTS &amp; ADAPTERS CONCEPTUAL MODEL</a:t>
+              <a:t>PORTS &amp; ADAPTERS CONCEPT</a:t>
             </a:r>
           </a:p>
           <a:p>
@@ -4057,7 +3500,7 @@
               </a:defRPr>
             </a:pPr>
             <a:r>
-              <a:t>Pillar 2A: Hexagonal Architecture Concept (Real-World Car Analogy)</a:t>
+              <a:t>Hexagonal Architecture Concept: Real-World Car Engine Analogy</a:t>
             </a:r>
           </a:p>
         </p:txBody>
@@ -4078,8 +3521,8 @@
         </p:blipFill>
         <p:spPr>
           <a:xfrm>
-            <a:off x="731520" y="1371600"/>
-            <a:ext cx="10698480" cy="4937760"/>
+            <a:off x="731520" y="1280160"/>
+            <a:ext cx="10698480" cy="6017895"/>
           </a:xfrm>
           <a:prstGeom prst="rect">
             <a:avLst/>
@@ -4143,7 +3586,7 @@
               </a:defRPr>
             </a:pPr>
             <a:r>
-              <a:t>APPLICATION INFRASTRUCTURE MAPPING</a:t>
+              <a:t>CODEBASE LAYOUT &amp; CLASS MAPPING</a:t>
             </a:r>
           </a:p>
           <a:p>
@@ -4156,7 +3599,7 @@
               </a:defRPr>
             </a:pPr>
             <a:r>
-              <a:t>Pillar 2B: Hexagonal Architecture in Satellite Codebase</a:t>
+              <a:t>Hexagonal Architecture in Satellite Codebase</a:t>
             </a:r>
           </a:p>
         </p:txBody>
@@ -4177,8 +3620,8 @@
         </p:blipFill>
         <p:spPr>
           <a:xfrm>
-            <a:off x="731520" y="1371600"/>
-            <a:ext cx="10698480" cy="4937760"/>
+            <a:off x="731520" y="1280160"/>
+            <a:ext cx="10698480" cy="6017895"/>
           </a:xfrm>
           <a:prstGeom prst="rect">
             <a:avLst/>
@@ -4242,7 +3685,7 @@
               </a:defRPr>
             </a:pPr>
             <a:r>
-              <a:t>CLEAN ARCHITECTURE LAYOUT</a:t>
+              <a:t>ADAPTER LAYER FLEXIBILITY</a:t>
             </a:r>
           </a:p>
           <a:p>
@@ -4255,166 +3698,35 @@
               </a:defRPr>
             </a:pPr>
             <a:r>
-              <a:t>Package Structure &amp; Separation of Concerns</a:t>
-            </a:r>
-          </a:p>
-        </p:txBody>
-      </p:sp>
-      <p:sp>
-        <p:nvSpPr>
-          <p:cNvPr id="3" name="Rounded Rectangle 2"/>
-          <p:cNvSpPr/>
+              <a:t>Hexagonal Superpower: Multi-Database Adapter Swapping Demo</a:t>
+            </a:r>
+          </a:p>
+        </p:txBody>
+      </p:sp>
+      <p:pic>
+        <p:nvPicPr>
+          <p:cNvPr id="3" name="Picture 2" descr="diagram_adapter_swapping.png"/>
+          <p:cNvPicPr>
+            <a:picLocks noChangeAspect="1"/>
+          </p:cNvPicPr>
           <p:nvPr/>
-        </p:nvSpPr>
+        </p:nvPicPr>
+        <p:blipFill>
+          <a:blip r:embed="rId2"/>
+          <a:stretch>
+            <a:fillRect/>
+          </a:stretch>
+        </p:blipFill>
         <p:spPr>
           <a:xfrm>
-            <a:off x="731520" y="1371600"/>
-            <a:ext cx="10698480" cy="4754880"/>
+            <a:off x="731520" y="1280160"/>
+            <a:ext cx="10698480" cy="6017895"/>
           </a:xfrm>
-          <a:prstGeom prst="roundRect">
+          <a:prstGeom prst="rect">
             <a:avLst/>
           </a:prstGeom>
-          <a:solidFill>
-            <a:srgbClr val="1E293B"/>
-          </a:solidFill>
-          <a:ln w="19050">
-            <a:solidFill>
-              <a:srgbClr val="334155"/>
-            </a:solidFill>
-          </a:ln>
         </p:spPr>
-        <p:style>
-          <a:lnRef idx="1">
-            <a:schemeClr val="accent1"/>
-          </a:lnRef>
-          <a:fillRef idx="3">
-            <a:schemeClr val="accent1"/>
-          </a:fillRef>
-          <a:effectRef idx="2">
-            <a:schemeClr val="accent1"/>
-          </a:effectRef>
-          <a:fontRef idx="minor">
-            <a:schemeClr val="lt1"/>
-          </a:fontRef>
-        </p:style>
-        <p:txBody>
-          <a:bodyPr rtlCol="0" anchor="ctr" wrap="square"/>
-          <a:lstStyle/>
-          <a:p>
-            <a:pPr algn="ctr">
-              <a:defRPr b="1" sz="1600">
-                <a:solidFill>
-                  <a:srgbClr val="F59E0B"/>
-                </a:solidFill>
-              </a:defRPr>
-            </a:pPr>
-            <a:r>
-              <a:t>com.satellite</a:t>
-            </a:r>
-          </a:p>
-          <a:p>
-            <a:pPr>
-              <a:defRPr sz="1400" b="1">
-                <a:solidFill>
-                  <a:srgbClr val="F8FAFC"/>
-                </a:solidFill>
-                <a:latin typeface="Courier New"/>
-              </a:defRPr>
-            </a:pPr>
-            <a:r>
-              <a:t>├── domain/                  </a:t>
-            </a:r>
-            <a:r>
-              <a:rPr b="0">
-                <a:solidFill>
-                  <a:srgbClr val="94A3B8"/>
-                </a:solidFill>
-                <a:latin typeface="Arial"/>
-              </a:rPr>
-              <a:t>🔴 PURE JAVA (Inner Core: Satellite, Orbit, Telemetry, Ports)</a:t>
-            </a:r>
-          </a:p>
-          <a:p>
-            <a:pPr>
-              <a:defRPr sz="1400" b="1">
-                <a:solidFill>
-                  <a:srgbClr val="F8FAFC"/>
-                </a:solidFill>
-                <a:latin typeface="Courier New"/>
-              </a:defRPr>
-            </a:pPr>
-            <a:r>
-              <a:t>├── application/             </a:t>
-            </a:r>
-            <a:r>
-              <a:rPr b="0">
-                <a:solidFill>
-                  <a:srgbClr val="94A3B8"/>
-                </a:solidFill>
-                <a:latin typeface="Arial"/>
-              </a:rPr>
-              <a:t>🟡 ORCHESTRATION LAYER (Services: LaunchSatelliteService)</a:t>
-            </a:r>
-          </a:p>
-          <a:p>
-            <a:pPr>
-              <a:defRPr sz="1400" b="1">
-                <a:solidFill>
-                  <a:srgbClr val="F8FAFC"/>
-                </a:solidFill>
-                <a:latin typeface="Courier New"/>
-              </a:defRPr>
-            </a:pPr>
-            <a:r>
-              <a:t>├── adapter/                 </a:t>
-            </a:r>
-            <a:r>
-              <a:rPr b="0">
-                <a:solidFill>
-                  <a:srgbClr val="94A3B8"/>
-                </a:solidFill>
-                <a:latin typeface="Arial"/>
-              </a:rPr>
-              <a:t>🟢 INFRASTRUCTURE LAYER (REST Controllers, JPA Entities, Mappers)</a:t>
-            </a:r>
-          </a:p>
-          <a:p>
-            <a:pPr>
-              <a:defRPr sz="1400" b="1">
-                <a:solidFill>
-                  <a:srgbClr val="F8FAFC"/>
-                </a:solidFill>
-                <a:latin typeface="Courier New"/>
-              </a:defRPr>
-            </a:pPr>
-            <a:r>
-              <a:t>└── config/                  </a:t>
-            </a:r>
-            <a:r>
-              <a:rPr b="0">
-                <a:solidFill>
-                  <a:srgbClr val="94A3B8"/>
-                </a:solidFill>
-                <a:latin typeface="Arial"/>
-              </a:rPr>
-              <a:t>🔵 COMPOSITION ROOT (BeanConfig: Wires Ports to Adapters)</a:t>
-            </a:r>
-          </a:p>
-          <a:p>
-            <a:br/>
-            <a:pPr>
-              <a:defRPr b="1" sz="1400">
-                <a:solidFill>
-                  <a:srgbClr val="10B981"/>
-                </a:solidFill>
-              </a:defRPr>
-            </a:pPr>
-            <a:r>
-              <a:t>Key Rule: Satellite (Domain Aggregate) ≠ SatelliteJpaEntity (Database Table) ≠ SatelliteResponse (REST DTO)</a:t>
-            </a:r>
-          </a:p>
-        </p:txBody>
-      </p:sp>
+      </p:pic>
     </p:spTree>
   </p:cSld>
   <p:clrMapOvr>
@@ -4472,7 +3784,7 @@
               </a:defRPr>
             </a:pPr>
             <a:r>
-              <a:t>AUTOMATED BUILD GATES</a:t>
+              <a:t>ARCHUNIT &amp; DEMO COMMANDS</a:t>
             </a:r>
           </a:p>
           <a:p>
@@ -4485,331 +3797,21 @@
               </a:defRPr>
             </a:pPr>
             <a:r>
-              <a:t>Pillar 3: ArchUnit — Architecture as Executable Code</a:t>
-            </a:r>
-          </a:p>
-        </p:txBody>
-      </p:sp>
-      <p:sp>
-        <p:nvSpPr>
-          <p:cNvPr id="3" name="Rounded Rectangle 2"/>
-          <p:cNvSpPr/>
+              <a:t>Automated Architecture Enforcement &amp; Testing</a:t>
+            </a:r>
+          </a:p>
+        </p:txBody>
+      </p:sp>
+      <p:sp>
+        <p:nvSpPr>
+          <p:cNvPr id="3" name="TextBox 2"/>
+          <p:cNvSpPr txBox="1"/>
           <p:nvPr/>
         </p:nvSpPr>
         <p:spPr>
           <a:xfrm>
             <a:off x="731520" y="1371600"/>
-            <a:ext cx="5486400" cy="4754880"/>
-          </a:xfrm>
-          <a:prstGeom prst="roundRect">
-            <a:avLst/>
-          </a:prstGeom>
-          <a:solidFill>
-            <a:srgbClr val="1E293B"/>
-          </a:solidFill>
-          <a:ln w="19050">
-            <a:solidFill>
-              <a:srgbClr val="334155"/>
-            </a:solidFill>
-          </a:ln>
-        </p:spPr>
-        <p:style>
-          <a:lnRef idx="1">
-            <a:schemeClr val="accent1"/>
-          </a:lnRef>
-          <a:fillRef idx="3">
-            <a:schemeClr val="accent1"/>
-          </a:fillRef>
-          <a:effectRef idx="2">
-            <a:schemeClr val="accent1"/>
-          </a:effectRef>
-          <a:fontRef idx="minor">
-            <a:schemeClr val="lt1"/>
-          </a:fontRef>
-        </p:style>
-        <p:txBody>
-          <a:bodyPr rtlCol="0" anchor="ctr" wrap="square"/>
-          <a:lstStyle/>
-          <a:p>
-            <a:pPr algn="ctr">
-              <a:defRPr b="1" sz="1600">
-                <a:solidFill>
-                  <a:srgbClr val="3B82F6"/>
-                </a:solidFill>
-              </a:defRPr>
-            </a:pPr>
-            <a:r>
-              <a:t>ArchUnit Test Code</a:t>
-            </a:r>
-          </a:p>
-          <a:p>
-            <a:pPr>
-              <a:defRPr sz="1100">
-                <a:solidFill>
-                  <a:srgbClr val="F8FAFC"/>
-                </a:solidFill>
-                <a:latin typeface="Courier New"/>
-              </a:defRPr>
-            </a:pPr>
-            <a:r>
-              <a:t>@ArchTest</a:t>
-            </a:r>
-          </a:p>
-          <a:p>
-            <a:pPr>
-              <a:defRPr sz="1100">
-                <a:solidFill>
-                  <a:srgbClr val="F8FAFC"/>
-                </a:solidFill>
-                <a:latin typeface="Courier New"/>
-              </a:defRPr>
-            </a:pPr>
-            <a:r>
-              <a:t>static final ArchRule domainMustBePure =</a:t>
-            </a:r>
-          </a:p>
-          <a:p>
-            <a:pPr>
-              <a:defRPr sz="1100">
-                <a:solidFill>
-                  <a:srgbClr val="F8FAFC"/>
-                </a:solidFill>
-                <a:latin typeface="Courier New"/>
-              </a:defRPr>
-            </a:pPr>
-            <a:r>
-              <a:t>  noClasses()</a:t>
-            </a:r>
-          </a:p>
-          <a:p>
-            <a:pPr>
-              <a:defRPr sz="1100">
-                <a:solidFill>
-                  <a:srgbClr val="F8FAFC"/>
-                </a:solidFill>
-                <a:latin typeface="Courier New"/>
-              </a:defRPr>
-            </a:pPr>
-            <a:r>
-              <a:t>    .that().resideInAPackage("..domain..")</a:t>
-            </a:r>
-          </a:p>
-          <a:p>
-            <a:pPr>
-              <a:defRPr sz="1100">
-                <a:solidFill>
-                  <a:srgbClr val="F8FAFC"/>
-                </a:solidFill>
-                <a:latin typeface="Courier New"/>
-              </a:defRPr>
-            </a:pPr>
-            <a:r>
-              <a:t>    .should().dependOnClassesThat()</a:t>
-            </a:r>
-          </a:p>
-          <a:p>
-            <a:pPr>
-              <a:defRPr sz="1100">
-                <a:solidFill>
-                  <a:srgbClr val="F8FAFC"/>
-                </a:solidFill>
-                <a:latin typeface="Courier New"/>
-              </a:defRPr>
-            </a:pPr>
-            <a:r>
-              <a:t>    .resideInAnyPackage(</a:t>
-            </a:r>
-          </a:p>
-          <a:p>
-            <a:pPr>
-              <a:defRPr sz="1100">
-                <a:solidFill>
-                  <a:srgbClr val="F8FAFC"/>
-                </a:solidFill>
-                <a:latin typeface="Courier New"/>
-              </a:defRPr>
-            </a:pPr>
-            <a:r>
-              <a:t>       "..adapter..", "..application..")</a:t>
-            </a:r>
-          </a:p>
-          <a:p>
-            <a:pPr>
-              <a:defRPr sz="1100">
-                <a:solidFill>
-                  <a:srgbClr val="F8FAFC"/>
-                </a:solidFill>
-                <a:latin typeface="Courier New"/>
-              </a:defRPr>
-            </a:pPr>
-            <a:r>
-              <a:t>    .because("Domain must be independent");</a:t>
-            </a:r>
-          </a:p>
-        </p:txBody>
-      </p:sp>
-      <p:sp>
-        <p:nvSpPr>
-          <p:cNvPr id="4" name="Rounded Rectangle 3"/>
-          <p:cNvSpPr/>
-          <p:nvPr/>
-        </p:nvSpPr>
-        <p:spPr>
-          <a:xfrm>
-            <a:off x="6492240" y="1371600"/>
-            <a:ext cx="4937760" cy="4754880"/>
-          </a:xfrm>
-          <a:prstGeom prst="roundRect">
-            <a:avLst/>
-          </a:prstGeom>
-          <a:solidFill>
-            <a:srgbClr val="1E293B"/>
-          </a:solidFill>
-          <a:ln w="19050">
-            <a:solidFill>
-              <a:srgbClr val="334155"/>
-            </a:solidFill>
-          </a:ln>
-        </p:spPr>
-        <p:style>
-          <a:lnRef idx="1">
-            <a:schemeClr val="accent1"/>
-          </a:lnRef>
-          <a:fillRef idx="3">
-            <a:schemeClr val="accent1"/>
-          </a:fillRef>
-          <a:effectRef idx="2">
-            <a:schemeClr val="accent1"/>
-          </a:effectRef>
-          <a:fontRef idx="minor">
-            <a:schemeClr val="lt1"/>
-          </a:fontRef>
-        </p:style>
-        <p:txBody>
-          <a:bodyPr rtlCol="0" anchor="ctr" wrap="square"/>
-          <a:lstStyle/>
-          <a:p>
-            <a:pPr algn="ctr">
-              <a:defRPr b="1" sz="1600">
-                <a:solidFill>
-                  <a:srgbClr val="F59E0B"/>
-                </a:solidFill>
-              </a:defRPr>
-            </a:pPr>
-            <a:r>
-              <a:t>14 Enforced Architectural Rules</a:t>
-            </a:r>
-          </a:p>
-          <a:p>
-            <a:pPr>
-              <a:defRPr sz="1300">
-                <a:solidFill>
-                  <a:srgbClr val="F8FAFC"/>
-                </a:solidFill>
-              </a:defRPr>
-            </a:pPr>
-            <a:r>
-              <a:t>✔ 1. Domain layer purity (Zero adapter/app dependencies)</a:t>
-            </a:r>
-          </a:p>
-          <a:p>
-            <a:pPr>
-              <a:defRPr sz="1300">
-                <a:solidFill>
-                  <a:srgbClr val="F8FAFC"/>
-                </a:solidFill>
-              </a:defRPr>
-            </a:pPr>
-            <a:r>
-              <a:t>✔ 2. No JPA/Spring annotations in domain models</a:t>
-            </a:r>
-          </a:p>
-          <a:p>
-            <a:pPr>
-              <a:defRPr sz="1300">
-                <a:solidFill>
-                  <a:srgbClr val="F8FAFC"/>
-                </a:solidFill>
-              </a:defRPr>
-            </a:pPr>
-            <a:r>
-              <a:t>✔ 3. Controllers must depend on Ports, not Services</a:t>
-            </a:r>
-          </a:p>
-          <a:p>
-            <a:pPr>
-              <a:defRPr sz="1300">
-                <a:solidFill>
-                  <a:srgbClr val="F8FAFC"/>
-                </a:solidFill>
-              </a:defRPr>
-            </a:pPr>
-            <a:r>
-              <a:t>✔ 4. Outbound adapters must implement outbound ports</a:t>
-            </a:r>
-          </a:p>
-          <a:p>
-            <a:pPr>
-              <a:defRPr sz="1300">
-                <a:solidFill>
-                  <a:srgbClr val="F8FAFC"/>
-                </a:solidFill>
-              </a:defRPr>
-            </a:pPr>
-            <a:r>
-              <a:t>✔ 5. Naming conventions (*Service, *Adapter, *Controller)</a:t>
-            </a:r>
-          </a:p>
-          <a:p>
-            <a:pPr>
-              <a:defRPr sz="1300">
-                <a:solidFill>
-                  <a:srgbClr val="F8FAFC"/>
-                </a:solidFill>
-              </a:defRPr>
-            </a:pPr>
-            <a:r>
-              <a:t>✔ 6. No cyclic dependencies between layers</a:t>
-            </a:r>
-          </a:p>
-        </p:txBody>
-      </p:sp>
-    </p:spTree>
-  </p:cSld>
-  <p:clrMapOvr>
-    <a:masterClrMapping/>
-  </p:clrMapOvr>
-</p:sld>
-</file>
-
-<file path=ppt/slides/slide8.xml><?xml version="1.0" encoding="utf-8"?>
-<p:sld xmlns:a="http://schemas.openxmlformats.org/drawingml/2006/main" xmlns:p="http://schemas.openxmlformats.org/presentationml/2006/main" xmlns:r="http://schemas.openxmlformats.org/officeDocument/2006/relationships">
-  <p:cSld>
-    <p:bg>
-      <p:bgPr>
-        <a:solidFill>
-          <a:srgbClr val="0F172A"/>
-        </a:solidFill>
-        <a:effectLst/>
-      </p:bgPr>
-    </p:bg>
-    <p:spTree>
-      <p:nvGrpSpPr>
-        <p:cNvPr id="1" name=""/>
-        <p:cNvGrpSpPr/>
-        <p:nvPr/>
-      </p:nvGrpSpPr>
-      <p:grpSpPr/>
-      <p:sp>
-        <p:nvSpPr>
-          <p:cNvPr id="2" name="TextBox 1"/>
-          <p:cNvSpPr txBox="1"/>
-          <p:nvPr/>
-        </p:nvSpPr>
-        <p:spPr>
-          <a:xfrm>
-            <a:off x="731520" y="365760"/>
-            <a:ext cx="10698480" cy="822960"/>
+            <a:ext cx="10698480" cy="4846320"/>
           </a:xfrm>
           <a:prstGeom prst="rect">
             <a:avLst/>
@@ -4817,159 +3819,84 @@
           <a:noFill/>
         </p:spPr>
         <p:txBody>
-          <a:bodyPr wrap="square" lIns="0" tIns="0" rIns="0" bIns="0">
+          <a:bodyPr wrap="square">
             <a:spAutoFit/>
           </a:bodyPr>
           <a:lstStyle/>
           <a:p>
             <a:pPr>
-              <a:defRPr sz="1100" b="1">
-                <a:solidFill>
-                  <a:srgbClr val="3B82F6"/>
-                </a:solidFill>
-                <a:latin typeface="Arial"/>
+              <a:defRPr b="1" sz="1800">
+                <a:solidFill>
+                  <a:srgbClr val="F59E0B"/>
+                </a:solidFill>
               </a:defRPr>
             </a:pPr>
             <a:r>
-              <a:t>HANDS-ON WALKTHROUGH</a:t>
+              <a:t>1. ArchUnit Build Gates (11 Mandatory Rules):</a:t>
             </a:r>
           </a:p>
           <a:p>
             <a:pPr>
-              <a:defRPr sz="2400" b="1">
+              <a:defRPr sz="1400">
                 <a:solidFill>
                   <a:srgbClr val="F8FAFC"/>
                 </a:solidFill>
-                <a:latin typeface="Arial"/>
               </a:defRPr>
             </a:pPr>
             <a:r>
-              <a:t>Live Demo Plan &amp; Execution Steps</a:t>
-            </a:r>
-          </a:p>
-        </p:txBody>
-      </p:sp>
-      <p:sp>
-        <p:nvSpPr>
-          <p:cNvPr id="3" name="Rounded Rectangle 2"/>
-          <p:cNvSpPr/>
-          <p:nvPr/>
-        </p:nvSpPr>
-        <p:spPr>
-          <a:xfrm>
-            <a:off x="731520" y="1645920"/>
-            <a:ext cx="3474720" cy="4389120"/>
-          </a:xfrm>
-          <a:prstGeom prst="roundRect">
-            <a:avLst/>
-          </a:prstGeom>
-          <a:solidFill>
-            <a:srgbClr val="1E293B"/>
-          </a:solidFill>
-          <a:ln w="19050">
-            <a:solidFill>
-              <a:srgbClr val="334155"/>
-            </a:solidFill>
-          </a:ln>
-        </p:spPr>
-        <p:style>
-          <a:lnRef idx="1">
-            <a:schemeClr val="accent1"/>
-          </a:lnRef>
-          <a:fillRef idx="3">
-            <a:schemeClr val="accent1"/>
-          </a:fillRef>
-          <a:effectRef idx="2">
-            <a:schemeClr val="accent1"/>
-          </a:effectRef>
-          <a:fontRef idx="minor">
-            <a:schemeClr val="lt1"/>
-          </a:fontRef>
-        </p:style>
-        <p:txBody>
-          <a:bodyPr rtlCol="0" anchor="ctr" wrap="square"/>
-          <a:lstStyle/>
-          <a:p>
-            <a:pPr algn="ctr">
-              <a:defRPr b="1" sz="1600">
-                <a:solidFill>
-                  <a:srgbClr val="F59E0B"/>
+              <a:t>  • Domain Purity: domain has zero dependencies on infrastructure, application, Spring, or JPA.</a:t>
+            </a:r>
+          </a:p>
+          <a:p>
+            <a:pPr>
+              <a:defRPr sz="1400">
+                <a:solidFill>
+                  <a:srgbClr val="F8FAFC"/>
                 </a:solidFill>
               </a:defRPr>
             </a:pPr>
             <a:r>
-              <a:t>Step 1: Code Tour</a:t>
+              <a:t>  • Port Isolation: Inbound &amp; Outbound ports reside strictly in domain.port package.</a:t>
+            </a:r>
+          </a:p>
+          <a:p>
+            <a:pPr>
+              <a:defRPr sz="1400">
+                <a:solidFill>
+                  <a:srgbClr val="F8FAFC"/>
+                </a:solidFill>
+              </a:defRPr>
+            </a:pPr>
+            <a:r>
+              <a:t>  • Controller Constraint: REST controllers depend ONLY on inbound ports (LaunchSatelliteUseCase).</a:t>
+            </a:r>
+          </a:p>
+          <a:p>
+            <a:pPr>
+              <a:defRPr sz="1400">
+                <a:solidFill>
+                  <a:srgbClr val="F8FAFC"/>
+                </a:solidFill>
+              </a:defRPr>
+            </a:pPr>
+            <a:r>
+              <a:t>  • Adapter Isolation: Driving adapters (REST) cannot call driven adapters (JPA).</a:t>
             </a:r>
           </a:p>
           <a:p>
             <a:br/>
             <a:pPr>
-              <a:defRPr sz="1400">
-                <a:solidFill>
-                  <a:srgbClr val="F8FAFC"/>
+              <a:defRPr b="1" sz="1800">
+                <a:solidFill>
+                  <a:srgbClr val="10B981"/>
                 </a:solidFill>
               </a:defRPr>
             </a:pPr>
             <a:r>
-              <a:t>Inspect Satellite.java aggregate, Orbit value object, and Hexagonal Architecture tests.</a:t>
-            </a:r>
-          </a:p>
-        </p:txBody>
-      </p:sp>
-      <p:sp>
-        <p:nvSpPr>
-          <p:cNvPr id="4" name="Rounded Rectangle 3"/>
-          <p:cNvSpPr/>
-          <p:nvPr/>
-        </p:nvSpPr>
-        <p:spPr>
-          <a:xfrm>
-            <a:off x="4389120" y="1645920"/>
-            <a:ext cx="3474720" cy="4389120"/>
-          </a:xfrm>
-          <a:prstGeom prst="roundRect">
-            <a:avLst/>
-          </a:prstGeom>
-          <a:solidFill>
-            <a:srgbClr val="1E293B"/>
-          </a:solidFill>
-          <a:ln w="19050">
-            <a:solidFill>
-              <a:srgbClr val="334155"/>
-            </a:solidFill>
-          </a:ln>
-        </p:spPr>
-        <p:style>
-          <a:lnRef idx="1">
-            <a:schemeClr val="accent1"/>
-          </a:lnRef>
-          <a:fillRef idx="3">
-            <a:schemeClr val="accent1"/>
-          </a:fillRef>
-          <a:effectRef idx="2">
-            <a:schemeClr val="accent1"/>
-          </a:effectRef>
-          <a:fontRef idx="minor">
-            <a:schemeClr val="lt1"/>
-          </a:fontRef>
-        </p:style>
-        <p:txBody>
-          <a:bodyPr rtlCol="0" anchor="ctr" wrap="square"/>
-          <a:lstStyle/>
-          <a:p>
-            <a:pPr algn="ctr">
-              <a:defRPr b="1" sz="1600">
-                <a:solidFill>
-                  <a:srgbClr val="F59E0B"/>
-                </a:solidFill>
-              </a:defRPr>
-            </a:pPr>
-            <a:r>
-              <a:t>Step 2: Break ArchUnit</a:t>
-            </a:r>
-          </a:p>
-          <a:p>
-            <a:br/>
+              <a:t>2. Execution &amp; Live Demo Commands:</a:t>
+            </a:r>
+          </a:p>
+          <a:p>
             <a:pPr>
               <a:defRPr sz="1400">
                 <a:solidFill>
@@ -4978,65 +3905,10 @@
               </a:defRPr>
             </a:pPr>
             <a:r>
-              <a:t>Add @Entity to Satellite.java -&gt; Run 'mvn test' -&gt; Watch build fail with explicit violation log!</a:t>
-            </a:r>
-          </a:p>
-        </p:txBody>
-      </p:sp>
-      <p:sp>
-        <p:nvSpPr>
-          <p:cNvPr id="5" name="Rounded Rectangle 4"/>
-          <p:cNvSpPr/>
-          <p:nvPr/>
-        </p:nvSpPr>
-        <p:spPr>
-          <a:xfrm>
-            <a:off x="7955279" y="1645920"/>
-            <a:ext cx="3474720" cy="4389120"/>
-          </a:xfrm>
-          <a:prstGeom prst="roundRect">
-            <a:avLst/>
-          </a:prstGeom>
-          <a:solidFill>
-            <a:srgbClr val="1E293B"/>
-          </a:solidFill>
-          <a:ln w="19050">
-            <a:solidFill>
-              <a:srgbClr val="334155"/>
-            </a:solidFill>
-          </a:ln>
-        </p:spPr>
-        <p:style>
-          <a:lnRef idx="1">
-            <a:schemeClr val="accent1"/>
-          </a:lnRef>
-          <a:fillRef idx="3">
-            <a:schemeClr val="accent1"/>
-          </a:fillRef>
-          <a:effectRef idx="2">
-            <a:schemeClr val="accent1"/>
-          </a:effectRef>
-          <a:fontRef idx="minor">
-            <a:schemeClr val="lt1"/>
-          </a:fontRef>
-        </p:style>
-        <p:txBody>
-          <a:bodyPr rtlCol="0" anchor="ctr" wrap="square"/>
-          <a:lstStyle/>
-          <a:p>
-            <a:pPr algn="ctr">
-              <a:defRPr b="1" sz="1600">
-                <a:solidFill>
-                  <a:srgbClr val="F59E0B"/>
-                </a:solidFill>
-              </a:defRPr>
-            </a:pPr>
-            <a:r>
-              <a:t>Step 3: REST API Execution</a:t>
-            </a:r>
-          </a:p>
-          <a:p>
-            <a:br/>
+              <a:t>  $ mvn clean test               # Runs 37 unit, integration &amp; ArchUnit tests (0 failures)</a:t>
+            </a:r>
+          </a:p>
+          <a:p>
             <a:pPr>
               <a:defRPr sz="1400">
                 <a:solidFill>
@@ -5045,350 +3917,19 @@
               </a:defRPr>
             </a:pPr>
             <a:r>
-              <a:t>Run 'mvn spring-boot:run' -&gt; Launch satellite -&gt; Update telemetry -&gt; Trigger automatic Anomaly Alert event.</a:t>
-            </a:r>
-          </a:p>
-        </p:txBody>
-      </p:sp>
-    </p:spTree>
-  </p:cSld>
-  <p:clrMapOvr>
-    <a:masterClrMapping/>
-  </p:clrMapOvr>
-</p:sld>
-</file>
-
-<file path=ppt/slides/slide9.xml><?xml version="1.0" encoding="utf-8"?>
-<p:sld xmlns:a="http://schemas.openxmlformats.org/drawingml/2006/main" xmlns:p="http://schemas.openxmlformats.org/presentationml/2006/main" xmlns:r="http://schemas.openxmlformats.org/officeDocument/2006/relationships">
-  <p:cSld>
-    <p:bg>
-      <p:bgPr>
-        <a:solidFill>
-          <a:srgbClr val="0F172A"/>
-        </a:solidFill>
-        <a:effectLst/>
-      </p:bgPr>
-    </p:bg>
-    <p:spTree>
-      <p:nvGrpSpPr>
-        <p:cNvPr id="1" name=""/>
-        <p:cNvGrpSpPr/>
-        <p:nvPr/>
-      </p:nvGrpSpPr>
-      <p:grpSpPr/>
-      <p:sp>
-        <p:nvSpPr>
-          <p:cNvPr id="2" name="TextBox 1"/>
-          <p:cNvSpPr txBox="1"/>
-          <p:nvPr/>
-        </p:nvSpPr>
-        <p:spPr>
-          <a:xfrm>
-            <a:off x="731520" y="365760"/>
-            <a:ext cx="10698480" cy="822960"/>
-          </a:xfrm>
-          <a:prstGeom prst="rect">
-            <a:avLst/>
-          </a:prstGeom>
-          <a:noFill/>
-        </p:spPr>
-        <p:txBody>
-          <a:bodyPr wrap="square" lIns="0" tIns="0" rIns="0" bIns="0">
-            <a:spAutoFit/>
-          </a:bodyPr>
-          <a:lstStyle/>
+              <a:t>  $ mvn spring-boot:run          # Launches live Spring Boot REST application on http://localhost:8080</a:t>
+            </a:r>
+          </a:p>
           <a:p>
             <a:pPr>
-              <a:defRPr sz="1100" b="1">
-                <a:solidFill>
-                  <a:srgbClr val="3B82F6"/>
-                </a:solidFill>
-                <a:latin typeface="Arial"/>
+              <a:defRPr sz="1400">
+                <a:solidFill>
+                  <a:srgbClr val="F8FAFC"/>
+                </a:solidFill>
               </a:defRPr>
             </a:pPr>
             <a:r>
-              <a:t>WHY ADOPT THIS PATTERN?</a:t>
-            </a:r>
-          </a:p>
-          <a:p>
-            <a:pPr>
-              <a:defRPr sz="2400" b="1">
-                <a:solidFill>
-                  <a:srgbClr val="F8FAFC"/>
-                </a:solidFill>
-                <a:latin typeface="Arial"/>
-              </a:defRPr>
-            </a:pPr>
-            <a:r>
-              <a:t>Key Business &amp; Technical Benefits</a:t>
-            </a:r>
-          </a:p>
-        </p:txBody>
-      </p:sp>
-      <p:sp>
-        <p:nvSpPr>
-          <p:cNvPr id="3" name="Rounded Rectangle 2"/>
-          <p:cNvSpPr/>
-          <p:nvPr/>
-        </p:nvSpPr>
-        <p:spPr>
-          <a:xfrm>
-            <a:off x="731520" y="1645920"/>
-            <a:ext cx="5212080" cy="2103120"/>
-          </a:xfrm>
-          <a:prstGeom prst="roundRect">
-            <a:avLst/>
-          </a:prstGeom>
-          <a:solidFill>
-            <a:srgbClr val="1E293B"/>
-          </a:solidFill>
-          <a:ln w="19050">
-            <a:solidFill>
-              <a:srgbClr val="334155"/>
-            </a:solidFill>
-          </a:ln>
-        </p:spPr>
-        <p:style>
-          <a:lnRef idx="1">
-            <a:schemeClr val="accent1"/>
-          </a:lnRef>
-          <a:fillRef idx="3">
-            <a:schemeClr val="accent1"/>
-          </a:fillRef>
-          <a:effectRef idx="2">
-            <a:schemeClr val="accent1"/>
-          </a:effectRef>
-          <a:fontRef idx="minor">
-            <a:schemeClr val="lt1"/>
-          </a:fontRef>
-        </p:style>
-        <p:txBody>
-          <a:bodyPr rtlCol="0" anchor="ctr" wrap="square"/>
-          <a:lstStyle/>
-          <a:p>
-            <a:pPr algn="ctr">
-              <a:defRPr b="1" sz="1600">
-                <a:solidFill>
-                  <a:srgbClr val="10B981"/>
-                </a:solidFill>
-              </a:defRPr>
-            </a:pPr>
-            <a:r>
-              <a:t>⚡ Ultra-Fast Unit Testing</a:t>
-            </a:r>
-          </a:p>
-          <a:p>
-            <a:br/>
-            <a:pPr>
-              <a:defRPr sz="1300">
-                <a:solidFill>
-                  <a:srgbClr val="F8FAFC"/>
-                </a:solidFill>
-              </a:defRPr>
-            </a:pPr>
-            <a:r>
-              <a:t>Domain logic unit tests run in milliseconds without booting Spring or DB containers.</a:t>
-            </a:r>
-          </a:p>
-        </p:txBody>
-      </p:sp>
-      <p:sp>
-        <p:nvSpPr>
-          <p:cNvPr id="4" name="Rounded Rectangle 3"/>
-          <p:cNvSpPr/>
-          <p:nvPr/>
-        </p:nvSpPr>
-        <p:spPr>
-          <a:xfrm>
-            <a:off x="6217920" y="1645920"/>
-            <a:ext cx="5212080" cy="2103120"/>
-          </a:xfrm>
-          <a:prstGeom prst="roundRect">
-            <a:avLst/>
-          </a:prstGeom>
-          <a:solidFill>
-            <a:srgbClr val="1E293B"/>
-          </a:solidFill>
-          <a:ln w="19050">
-            <a:solidFill>
-              <a:srgbClr val="334155"/>
-            </a:solidFill>
-          </a:ln>
-        </p:spPr>
-        <p:style>
-          <a:lnRef idx="1">
-            <a:schemeClr val="accent1"/>
-          </a:lnRef>
-          <a:fillRef idx="3">
-            <a:schemeClr val="accent1"/>
-          </a:fillRef>
-          <a:effectRef idx="2">
-            <a:schemeClr val="accent1"/>
-          </a:effectRef>
-          <a:fontRef idx="minor">
-            <a:schemeClr val="lt1"/>
-          </a:fontRef>
-        </p:style>
-        <p:txBody>
-          <a:bodyPr rtlCol="0" anchor="ctr" wrap="square"/>
-          <a:lstStyle/>
-          <a:p>
-            <a:pPr algn="ctr">
-              <a:defRPr b="1" sz="1600">
-                <a:solidFill>
-                  <a:srgbClr val="10B981"/>
-                </a:solidFill>
-              </a:defRPr>
-            </a:pPr>
-            <a:r>
-              <a:t>🛡️ Zero Architectural Drift</a:t>
-            </a:r>
-          </a:p>
-          <a:p>
-            <a:br/>
-            <a:pPr>
-              <a:defRPr sz="1300">
-                <a:solidFill>
-                  <a:srgbClr val="F8FAFC"/>
-                </a:solidFill>
-              </a:defRPr>
-            </a:pPr>
-            <a:r>
-              <a:t>ArchUnit fails CI/CD builds instantly if anyone breaks layer boundaries.</a:t>
-            </a:r>
-          </a:p>
-        </p:txBody>
-      </p:sp>
-      <p:sp>
-        <p:nvSpPr>
-          <p:cNvPr id="5" name="Rounded Rectangle 4"/>
-          <p:cNvSpPr/>
-          <p:nvPr/>
-        </p:nvSpPr>
-        <p:spPr>
-          <a:xfrm>
-            <a:off x="731520" y="3931920"/>
-            <a:ext cx="5212080" cy="2103120"/>
-          </a:xfrm>
-          <a:prstGeom prst="roundRect">
-            <a:avLst/>
-          </a:prstGeom>
-          <a:solidFill>
-            <a:srgbClr val="1E293B"/>
-          </a:solidFill>
-          <a:ln w="19050">
-            <a:solidFill>
-              <a:srgbClr val="334155"/>
-            </a:solidFill>
-          </a:ln>
-        </p:spPr>
-        <p:style>
-          <a:lnRef idx="1">
-            <a:schemeClr val="accent1"/>
-          </a:lnRef>
-          <a:fillRef idx="3">
-            <a:schemeClr val="accent1"/>
-          </a:fillRef>
-          <a:effectRef idx="2">
-            <a:schemeClr val="accent1"/>
-          </a:effectRef>
-          <a:fontRef idx="minor">
-            <a:schemeClr val="lt1"/>
-          </a:fontRef>
-        </p:style>
-        <p:txBody>
-          <a:bodyPr rtlCol="0" anchor="ctr" wrap="square"/>
-          <a:lstStyle/>
-          <a:p>
-            <a:pPr algn="ctr">
-              <a:defRPr b="1" sz="1600">
-                <a:solidFill>
-                  <a:srgbClr val="10B981"/>
-                </a:solidFill>
-              </a:defRPr>
-            </a:pPr>
-            <a:r>
-              <a:t>🔄 Seamless Infrastructure Swaps</a:t>
-            </a:r>
-          </a:p>
-          <a:p>
-            <a:br/>
-            <a:pPr>
-              <a:defRPr sz="1300">
-                <a:solidFill>
-                  <a:srgbClr val="F8FAFC"/>
-                </a:solidFill>
-              </a:defRPr>
-            </a:pPr>
-            <a:r>
-              <a:t>Replace JPA with MongoDB or Spring Events with Kafka without touching 1 line of domain code.</a:t>
-            </a:r>
-          </a:p>
-        </p:txBody>
-      </p:sp>
-      <p:sp>
-        <p:nvSpPr>
-          <p:cNvPr id="6" name="Rounded Rectangle 5"/>
-          <p:cNvSpPr/>
-          <p:nvPr/>
-        </p:nvSpPr>
-        <p:spPr>
-          <a:xfrm>
-            <a:off x="6217920" y="3931920"/>
-            <a:ext cx="5212080" cy="2103120"/>
-          </a:xfrm>
-          <a:prstGeom prst="roundRect">
-            <a:avLst/>
-          </a:prstGeom>
-          <a:solidFill>
-            <a:srgbClr val="1E293B"/>
-          </a:solidFill>
-          <a:ln w="19050">
-            <a:solidFill>
-              <a:srgbClr val="334155"/>
-            </a:solidFill>
-          </a:ln>
-        </p:spPr>
-        <p:style>
-          <a:lnRef idx="1">
-            <a:schemeClr val="accent1"/>
-          </a:lnRef>
-          <a:fillRef idx="3">
-            <a:schemeClr val="accent1"/>
-          </a:fillRef>
-          <a:effectRef idx="2">
-            <a:schemeClr val="accent1"/>
-          </a:effectRef>
-          <a:fontRef idx="minor">
-            <a:schemeClr val="lt1"/>
-          </a:fontRef>
-        </p:style>
-        <p:txBody>
-          <a:bodyPr rtlCol="0" anchor="ctr" wrap="square"/>
-          <a:lstStyle/>
-          <a:p>
-            <a:pPr algn="ctr">
-              <a:defRPr b="1" sz="1600">
-                <a:solidFill>
-                  <a:srgbClr val="10B981"/>
-                </a:solidFill>
-              </a:defRPr>
-            </a:pPr>
-            <a:r>
-              <a:t>🎯 High Business Alignment</a:t>
-            </a:r>
-          </a:p>
-          <a:p>
-            <a:br/>
-            <a:pPr>
-              <a:defRPr sz="1300">
-                <a:solidFill>
-                  <a:srgbClr val="F8FAFC"/>
-                </a:solidFill>
-              </a:defRPr>
-            </a:pPr>
-            <a:r>
-              <a:t>Domain code speaks the exact language of satellite flight operations.</a:t>
+              <a:t>  $ curl -X POST .../satellites  # Launches new satellite &amp; persists via SatelliteRepository port</a:t>
             </a:r>
           </a:p>
         </p:txBody>

</xml_diff>

<commit_message>
docs: add HD diagrams modeled after user reference images (Primary/Secondary Adapters, Concentric Onion, Ubiquitous Language) and push to GitHub
</commit_message>
<xml_diff>
--- a/Satellite_Architecture_DDD_Hexagonal_ArchUnit.pptx
+++ b/Satellite_Architecture_DDD_Hexagonal_ArchUnit.pptx
@@ -3388,7 +3388,7 @@
               </a:defRPr>
             </a:pPr>
             <a:r>
-              <a:t>CORE CONCEPTS</a:t>
+              <a:t>WATA / HERBERTO GRAÇA SPECIFICATION</a:t>
             </a:r>
           </a:p>
           <a:p>
@@ -3401,14 +3401,14 @@
               </a:defRPr>
             </a:pPr>
             <a:r>
-              <a:t>Domain-Driven Design (DDD) Core Architecture</a:t>
+              <a:t>Hexagonal Architecture: Primary (Driving) &amp; Secondary (Driven) Adapters</a:t>
             </a:r>
           </a:p>
         </p:txBody>
       </p:sp>
       <p:pic>
         <p:nvPicPr>
-          <p:cNvPr id="3" name="Picture 2" descr="diagram_ddd.png"/>
+          <p:cNvPr id="3" name="Picture 2" descr="diagram_hexagonal_primary_secondary.png"/>
           <p:cNvPicPr>
             <a:picLocks noChangeAspect="1"/>
           </p:cNvPicPr>
@@ -3487,7 +3487,7 @@
               </a:defRPr>
             </a:pPr>
             <a:r>
-              <a:t>PORTS &amp; ADAPTERS CONCEPT</a:t>
+              <a:t>ARCHITECTURAL ISOLATION</a:t>
             </a:r>
           </a:p>
           <a:p>
@@ -3500,14 +3500,14 @@
               </a:defRPr>
             </a:pPr>
             <a:r>
-              <a:t>Hexagonal Architecture Concept: Real-World Car Engine Analogy</a:t>
+              <a:t>Onion &amp; Hexagonal Concentric Ring Dependency Rules</a:t>
             </a:r>
           </a:p>
         </p:txBody>
       </p:sp>
       <p:pic>
         <p:nvPicPr>
-          <p:cNvPr id="3" name="Picture 2" descr="diagram_car_analogy.png"/>
+          <p:cNvPr id="3" name="Picture 2" descr="diagram_onion_concentric.png"/>
           <p:cNvPicPr>
             <a:picLocks noChangeAspect="1"/>
           </p:cNvPicPr>
@@ -3586,7 +3586,7 @@
               </a:defRPr>
             </a:pPr>
             <a:r>
-              <a:t>CODEBASE LAYOUT &amp; CLASS MAPPING</a:t>
+              <a:t>DOMAIN DISTILLATION</a:t>
             </a:r>
           </a:p>
           <a:p>
@@ -3599,14 +3599,14 @@
               </a:defRPr>
             </a:pPr>
             <a:r>
-              <a:t>Hexagonal Architecture in Satellite Codebase</a:t>
+              <a:t>Domain-Driven Design (DDD): Ubiquitous Language &amp; Subdomains</a:t>
             </a:r>
           </a:p>
         </p:txBody>
       </p:sp>
       <p:pic>
         <p:nvPicPr>
-          <p:cNvPr id="3" name="Picture 2" descr="diagram_satellite_hex.png"/>
+          <p:cNvPr id="3" name="Picture 2" descr="diagram_ddd_ubiquitous_language.png"/>
           <p:cNvPicPr>
             <a:picLocks noChangeAspect="1"/>
           </p:cNvPicPr>

</xml_diff>

<commit_message>
docs: add Herberto Graca Explicit Architecture diagram based on awesome-software-architecture spec and update PPTX + README
</commit_message>
<xml_diff>
--- a/Satellite_Architecture_DDD_Hexagonal_ArchUnit.pptx
+++ b/Satellite_Architecture_DDD_Hexagonal_ArchUnit.pptx
@@ -3218,7 +3218,7 @@
               </a:defRPr>
             </a:pPr>
             <a:r>
-              <a:t>ARCHITECTURAL CONTEXT</a:t>
+              <a:t>AWESOME SOFTWARE ARCHITECTURE SPEC</a:t>
             </a:r>
           </a:p>
           <a:p>
@@ -3231,106 +3231,35 @@
               </a:defRPr>
             </a:pPr>
             <a:r>
-              <a:t>Why Move Beyond Traditional 3-Tier Layered Java?</a:t>
-            </a:r>
-          </a:p>
-        </p:txBody>
-      </p:sp>
-      <p:sp>
-        <p:nvSpPr>
-          <p:cNvPr id="3" name="TextBox 2"/>
-          <p:cNvSpPr txBox="1"/>
+              <a:t>Herberto Graça Explicit Architecture — Satellite System Mapping</a:t>
+            </a:r>
+          </a:p>
+        </p:txBody>
+      </p:sp>
+      <p:pic>
+        <p:nvPicPr>
+          <p:cNvPr id="3" name="Picture 2" descr="diagram_explicit_architecture.png"/>
+          <p:cNvPicPr>
+            <a:picLocks noChangeAspect="1"/>
+          </p:cNvPicPr>
           <p:nvPr/>
-        </p:nvSpPr>
+        </p:nvPicPr>
+        <p:blipFill>
+          <a:blip r:embed="rId2"/>
+          <a:stretch>
+            <a:fillRect/>
+          </a:stretch>
+        </p:blipFill>
         <p:spPr>
           <a:xfrm>
-            <a:off x="731520" y="1371600"/>
-            <a:ext cx="10698480" cy="4846320"/>
+            <a:off x="731520" y="1280160"/>
+            <a:ext cx="10698480" cy="6017895"/>
           </a:xfrm>
           <a:prstGeom prst="rect">
             <a:avLst/>
           </a:prstGeom>
-          <a:noFill/>
         </p:spPr>
-        <p:txBody>
-          <a:bodyPr wrap="square">
-            <a:spAutoFit/>
-          </a:bodyPr>
-          <a:lstStyle/>
-          <a:p>
-            <a:pPr>
-              <a:defRPr b="1" sz="2000">
-                <a:solidFill>
-                  <a:srgbClr val="F59E0B"/>
-                </a:solidFill>
-              </a:defRPr>
-            </a:pPr>
-            <a:r>
-              <a:t>Traditional 3-Tier Layered Architecture Problems:</a:t>
-            </a:r>
-          </a:p>
-          <a:p>
-            <a:pPr>
-              <a:defRPr sz="1600">
-                <a:solidFill>
-                  <a:srgbClr val="F8FAFC"/>
-                </a:solidFill>
-              </a:defRPr>
-            </a:pPr>
-            <a:r>
-              <a:t>• Database-Centric Design: JPA @Entity classes contaminate business logic; schema changes break domain rules.</a:t>
-            </a:r>
-          </a:p>
-          <a:p>
-            <a:pPr>
-              <a:defRPr sz="1600">
-                <a:solidFill>
-                  <a:srgbClr val="F8FAFC"/>
-                </a:solidFill>
-              </a:defRPr>
-            </a:pPr>
-            <a:r>
-              <a:t>• Framework Tight Coupling: @Service, @Autowired, and Jackson annotations scattered throughout business logic.</a:t>
-            </a:r>
-          </a:p>
-          <a:p>
-            <a:pPr>
-              <a:defRPr sz="1600">
-                <a:solidFill>
-                  <a:srgbClr val="F8FAFC"/>
-                </a:solidFill>
-              </a:defRPr>
-            </a:pPr>
-            <a:r>
-              <a:t>• Anemic Domain Models: Dumb POJOs with getters/setters; business logic trapped inside procedural services.</a:t>
-            </a:r>
-          </a:p>
-          <a:p>
-            <a:pPr>
-              <a:defRPr sz="1600">
-                <a:solidFill>
-                  <a:srgbClr val="F8FAFC"/>
-                </a:solidFill>
-              </a:defRPr>
-            </a:pPr>
-            <a:r>
-              <a:t>• Slow Test Feedback: Unit tests require booting Spring Context or mocking complex database repositories.</a:t>
-            </a:r>
-          </a:p>
-          <a:p>
-            <a:pPr>
-              <a:defRPr sz="1600">
-                <a:solidFill>
-                  <a:srgbClr val="F8FAFC"/>
-                </a:solidFill>
-              </a:defRPr>
-            </a:pPr>
-            <a:r>
-              <a:t>• Architectural Decay: Without automated guardrails, developers break layer boundaries over time.</a:t>
-            </a:r>
-          </a:p>
-        </p:txBody>
-      </p:sp>
+      </p:pic>
     </p:spTree>
   </p:cSld>
   <p:clrMapOvr>

</xml_diff>

<commit_message>
docs: add 14-slide presentation deck and comprehensive What/Why/Components/Implementation/Challenges breakdown for DDD, Hexagonal, and ArchUnit
</commit_message>
<xml_diff>
--- a/Satellite_Architecture_DDD_Hexagonal_ArchUnit.pptx
+++ b/Satellite_Architecture_DDD_Hexagonal_ArchUnit.pptx
@@ -12,6 +12,13 @@
     <p:sldId id="260" r:id="rId11"/>
     <p:sldId id="261" r:id="rId12"/>
     <p:sldId id="262" r:id="rId13"/>
+    <p:sldId id="263" r:id="rId14"/>
+    <p:sldId id="264" r:id="rId15"/>
+    <p:sldId id="265" r:id="rId16"/>
+    <p:sldId id="266" r:id="rId17"/>
+    <p:sldId id="267" r:id="rId18"/>
+    <p:sldId id="268" r:id="rId19"/>
+    <p:sldId id="269" r:id="rId20"/>
   </p:sldIdLst>
   <p:sldSz cx="12191695" cy="6858000" type="screen4x3"/>
   <p:notesSz cx="6858000" cy="9144000"/>
@@ -3111,7 +3118,7 @@
         <p:spPr>
           <a:xfrm>
             <a:off x="914400" y="2011680"/>
-            <a:ext cx="10332720" cy="2743200"/>
+            <a:ext cx="10332720" cy="3200400"/>
           </a:xfrm>
           <a:prstGeom prst="rect">
             <a:avLst/>
@@ -3156,7 +3163,7 @@
               </a:defRPr>
             </a:pPr>
             <a:r>
-              <a:t>Reference Architecture &amp; Live Demo Guide for Enterprise Java 21 Applications</a:t>
+              <a:t>Complete Architectural Blueprint, Codebase Mapping, &amp; Presentation Deck</a:t>
             </a:r>
           </a:p>
         </p:txBody>
@@ -3169,7 +3176,7 @@
 </p:sld>
 </file>
 
-<file path=ppt/slides/slide2.xml><?xml version="1.0" encoding="utf-8"?>
+<file path=ppt/slides/slide10.xml><?xml version="1.0" encoding="utf-8"?>
 <p:sld xmlns:a="http://schemas.openxmlformats.org/drawingml/2006/main" xmlns:p="http://schemas.openxmlformats.org/presentationml/2006/main" xmlns:r="http://schemas.openxmlformats.org/officeDocument/2006/relationships">
   <p:cSld>
     <p:bg>
@@ -3218,7 +3225,7 @@
               </a:defRPr>
             </a:pPr>
             <a:r>
-              <a:t>AWESOME SOFTWARE ARCHITECTURE SPEC</a:t>
+              <a:t>PART 2 — HEXAGONAL ARCHITECTURE</a:t>
             </a:r>
           </a:p>
           <a:p>
@@ -3231,14 +3238,14 @@
               </a:defRPr>
             </a:pPr>
             <a:r>
-              <a:t>Herberto Graça Explicit Architecture — Satellite System Mapping</a:t>
+              <a:t>Multi-Database Adapter Swapping (SQL vs NoSQL)</a:t>
             </a:r>
           </a:p>
         </p:txBody>
       </p:sp>
       <p:pic>
         <p:nvPicPr>
-          <p:cNvPr id="3" name="Picture 2" descr="diagram_explicit_architecture.png"/>
+          <p:cNvPr id="3" name="Picture 2" descr="diagram_adapter_swapping.png"/>
           <p:cNvPicPr>
             <a:picLocks noChangeAspect="1"/>
           </p:cNvPicPr>
@@ -3268,6 +3275,941 @@
 </p:sld>
 </file>
 
+<file path=ppt/slides/slide11.xml><?xml version="1.0" encoding="utf-8"?>
+<p:sld xmlns:a="http://schemas.openxmlformats.org/drawingml/2006/main" xmlns:p="http://schemas.openxmlformats.org/presentationml/2006/main" xmlns:r="http://schemas.openxmlformats.org/officeDocument/2006/relationships">
+  <p:cSld>
+    <p:bg>
+      <p:bgPr>
+        <a:solidFill>
+          <a:srgbClr val="0F172A"/>
+        </a:solidFill>
+        <a:effectLst/>
+      </p:bgPr>
+    </p:bg>
+    <p:spTree>
+      <p:nvGrpSpPr>
+        <p:cNvPr id="1" name=""/>
+        <p:cNvGrpSpPr/>
+        <p:nvPr/>
+      </p:nvGrpSpPr>
+      <p:grpSpPr/>
+      <p:sp>
+        <p:nvSpPr>
+          <p:cNvPr id="2" name="TextBox 1"/>
+          <p:cNvSpPr txBox="1"/>
+          <p:nvPr/>
+        </p:nvSpPr>
+        <p:spPr>
+          <a:xfrm>
+            <a:off x="731520" y="365760"/>
+            <a:ext cx="10698480" cy="822960"/>
+          </a:xfrm>
+          <a:prstGeom prst="rect">
+            <a:avLst/>
+          </a:prstGeom>
+          <a:noFill/>
+        </p:spPr>
+        <p:txBody>
+          <a:bodyPr wrap="square" lIns="0" tIns="0" rIns="0" bIns="0">
+            <a:spAutoFit/>
+          </a:bodyPr>
+          <a:lstStyle/>
+          <a:p>
+            <a:pPr>
+              <a:defRPr sz="1100" b="1">
+                <a:solidFill>
+                  <a:srgbClr val="3B82F6"/>
+                </a:solidFill>
+                <a:latin typeface="Arial"/>
+              </a:defRPr>
+            </a:pPr>
+            <a:r>
+              <a:t>PART 3 — ARCHUNIT ENFORCEMENT</a:t>
+            </a:r>
+          </a:p>
+          <a:p>
+            <a:pPr>
+              <a:defRPr sz="2400" b="1">
+                <a:solidFill>
+                  <a:srgbClr val="F8FAFC"/>
+                </a:solidFill>
+                <a:latin typeface="Arial"/>
+              </a:defRPr>
+            </a:pPr>
+            <a:r>
+              <a:t>ArchUnit Architecture Enforcement: What &amp; Why</a:t>
+            </a:r>
+          </a:p>
+        </p:txBody>
+      </p:sp>
+      <p:sp>
+        <p:nvSpPr>
+          <p:cNvPr id="3" name="TextBox 2"/>
+          <p:cNvSpPr txBox="1"/>
+          <p:nvPr/>
+        </p:nvSpPr>
+        <p:spPr>
+          <a:xfrm>
+            <a:off x="731520" y="1371600"/>
+            <a:ext cx="10698480" cy="4846320"/>
+          </a:xfrm>
+          <a:prstGeom prst="rect">
+            <a:avLst/>
+          </a:prstGeom>
+          <a:noFill/>
+        </p:spPr>
+        <p:txBody>
+          <a:bodyPr wrap="square">
+            <a:spAutoFit/>
+          </a:bodyPr>
+          <a:lstStyle/>
+          <a:p>
+            <a:pPr>
+              <a:defRPr b="1" sz="2000">
+                <a:solidFill>
+                  <a:srgbClr val="F59E0B"/>
+                </a:solidFill>
+              </a:defRPr>
+            </a:pPr>
+            <a:r>
+              <a:t>What is ArchUnit?</a:t>
+            </a:r>
+          </a:p>
+          <a:p>
+            <a:pPr>
+              <a:defRPr sz="1500">
+                <a:solidFill>
+                  <a:srgbClr val="F8FAFC"/>
+                </a:solidFill>
+              </a:defRPr>
+            </a:pPr>
+            <a:r>
+              <a:t>• A Java architecture testing library that checks Java bytecode (.class files) using fluent JUnit 5 tests.</a:t>
+            </a:r>
+          </a:p>
+          <a:p>
+            <a:pPr>
+              <a:defRPr sz="1500">
+                <a:solidFill>
+                  <a:srgbClr val="F8FAFC"/>
+                </a:solidFill>
+              </a:defRPr>
+            </a:pPr>
+            <a:r>
+              <a:t>• Analyzes package dependencies, class naming conventions, annotation rules, and layer isolation.</a:t>
+            </a:r>
+          </a:p>
+          <a:p>
+            <a:br/>
+            <a:pPr>
+              <a:defRPr b="1" sz="2000">
+                <a:solidFill>
+                  <a:srgbClr val="10B981"/>
+                </a:solidFill>
+              </a:defRPr>
+            </a:pPr>
+            <a:r>
+              <a:t>Why Do We Need ArchUnit?</a:t>
+            </a:r>
+          </a:p>
+          <a:p>
+            <a:pPr>
+              <a:defRPr sz="1500">
+                <a:solidFill>
+                  <a:srgbClr val="F8FAFC"/>
+                </a:solidFill>
+              </a:defRPr>
+            </a:pPr>
+            <a:r>
+              <a:t>• Automates Code Reviews: Architecture rules are checked on every commit in CI/CD pipelines.</a:t>
+            </a:r>
+          </a:p>
+          <a:p>
+            <a:pPr>
+              <a:defRPr sz="1500">
+                <a:solidFill>
+                  <a:srgbClr val="F8FAFC"/>
+                </a:solidFill>
+              </a:defRPr>
+            </a:pPr>
+            <a:r>
+              <a:t>• Prevents Architectural Erosion: Prevents quick shortcuts (e.g. Controller calling DB Repository directly).</a:t>
+            </a:r>
+          </a:p>
+          <a:p>
+            <a:pPr>
+              <a:defRPr sz="1500">
+                <a:solidFill>
+                  <a:srgbClr val="F8FAFC"/>
+                </a:solidFill>
+              </a:defRPr>
+            </a:pPr>
+            <a:r>
+              <a:t>• Runs as a Pre-Packaging Build Gate: Executes during mvn test — FAILS THE BUILD before packaging or deployment!</a:t>
+            </a:r>
+          </a:p>
+        </p:txBody>
+      </p:sp>
+    </p:spTree>
+  </p:cSld>
+  <p:clrMapOvr>
+    <a:masterClrMapping/>
+  </p:clrMapOvr>
+</p:sld>
+</file>
+
+<file path=ppt/slides/slide12.xml><?xml version="1.0" encoding="utf-8"?>
+<p:sld xmlns:a="http://schemas.openxmlformats.org/drawingml/2006/main" xmlns:p="http://schemas.openxmlformats.org/presentationml/2006/main" xmlns:r="http://schemas.openxmlformats.org/officeDocument/2006/relationships">
+  <p:cSld>
+    <p:bg>
+      <p:bgPr>
+        <a:solidFill>
+          <a:srgbClr val="0F172A"/>
+        </a:solidFill>
+        <a:effectLst/>
+      </p:bgPr>
+    </p:bg>
+    <p:spTree>
+      <p:nvGrpSpPr>
+        <p:cNvPr id="1" name=""/>
+        <p:cNvGrpSpPr/>
+        <p:nvPr/>
+      </p:nvGrpSpPr>
+      <p:grpSpPr/>
+      <p:sp>
+        <p:nvSpPr>
+          <p:cNvPr id="2" name="TextBox 1"/>
+          <p:cNvSpPr txBox="1"/>
+          <p:nvPr/>
+        </p:nvSpPr>
+        <p:spPr>
+          <a:xfrm>
+            <a:off x="731520" y="365760"/>
+            <a:ext cx="10698480" cy="822960"/>
+          </a:xfrm>
+          <a:prstGeom prst="rect">
+            <a:avLst/>
+          </a:prstGeom>
+          <a:noFill/>
+        </p:spPr>
+        <p:txBody>
+          <a:bodyPr wrap="square" lIns="0" tIns="0" rIns="0" bIns="0">
+            <a:spAutoFit/>
+          </a:bodyPr>
+          <a:lstStyle/>
+          <a:p>
+            <a:pPr>
+              <a:defRPr sz="1100" b="1">
+                <a:solidFill>
+                  <a:srgbClr val="3B82F6"/>
+                </a:solidFill>
+                <a:latin typeface="Arial"/>
+              </a:defRPr>
+            </a:pPr>
+            <a:r>
+              <a:t>PART 3 — ARCHUNIT ENFORCEMENT</a:t>
+            </a:r>
+          </a:p>
+          <a:p>
+            <a:pPr>
+              <a:defRPr sz="2400" b="1">
+                <a:solidFill>
+                  <a:srgbClr val="F8FAFC"/>
+                </a:solidFill>
+                <a:latin typeface="Arial"/>
+              </a:defRPr>
+            </a:pPr>
+            <a:r>
+              <a:t>ArchUnit Rules &amp; Build Gates in Satellite System</a:t>
+            </a:r>
+          </a:p>
+        </p:txBody>
+      </p:sp>
+      <p:sp>
+        <p:nvSpPr>
+          <p:cNvPr id="3" name="TextBox 2"/>
+          <p:cNvSpPr txBox="1"/>
+          <p:nvPr/>
+        </p:nvSpPr>
+        <p:spPr>
+          <a:xfrm>
+            <a:off x="731520" y="1371600"/>
+            <a:ext cx="10698480" cy="4846320"/>
+          </a:xfrm>
+          <a:prstGeom prst="rect">
+            <a:avLst/>
+          </a:prstGeom>
+          <a:noFill/>
+        </p:spPr>
+        <p:txBody>
+          <a:bodyPr wrap="square">
+            <a:spAutoFit/>
+          </a:bodyPr>
+          <a:lstStyle/>
+          <a:p>
+            <a:pPr>
+              <a:defRPr b="1" sz="1600">
+                <a:solidFill>
+                  <a:srgbClr val="3B82F6"/>
+                </a:solidFill>
+              </a:defRPr>
+            </a:pPr>
+            <a:r>
+              <a:t>• Domain Purity Rule:</a:t>
+            </a:r>
+          </a:p>
+          <a:p>
+            <a:pPr>
+              <a:defRPr sz="1300">
+                <a:solidFill>
+                  <a:srgbClr val="F8FAFC"/>
+                </a:solidFill>
+              </a:defRPr>
+            </a:pPr>
+            <a:r>
+              <a:t>   noClasses().that().resideInAPackage('..domain..').should().dependOnClassesThat().resideInAPackage('..infrastructure..')</a:t>
+            </a:r>
+          </a:p>
+          <a:p>
+            <a:pPr>
+              <a:defRPr b="1" sz="1600">
+                <a:solidFill>
+                  <a:srgbClr val="3B82F6"/>
+                </a:solidFill>
+              </a:defRPr>
+            </a:pPr>
+            <a:r>
+              <a:t>• No Spring/JPA in Domain:</a:t>
+            </a:r>
+          </a:p>
+          <a:p>
+            <a:pPr>
+              <a:defRPr sz="1300">
+                <a:solidFill>
+                  <a:srgbClr val="F8FAFC"/>
+                </a:solidFill>
+              </a:defRPr>
+            </a:pPr>
+            <a:r>
+              <a:t>   noClasses().that().resideInAPackage('..domain.model..').should().beAnnotatedWith('..Entity')</a:t>
+            </a:r>
+          </a:p>
+          <a:p>
+            <a:pPr>
+              <a:defRPr b="1" sz="1600">
+                <a:solidFill>
+                  <a:srgbClr val="3B82F6"/>
+                </a:solidFill>
+              </a:defRPr>
+            </a:pPr>
+            <a:r>
+              <a:t>• Controller Port Constraint:</a:t>
+            </a:r>
+          </a:p>
+          <a:p>
+            <a:pPr>
+              <a:defRPr sz="1300">
+                <a:solidFill>
+                  <a:srgbClr val="F8FAFC"/>
+                </a:solidFill>
+              </a:defRPr>
+            </a:pPr>
+            <a:r>
+              <a:t>   noClasses().that().resideInAPackage('..rest..').should().dependOnClassesThat().resideInAPackage('..application..')</a:t>
+            </a:r>
+          </a:p>
+          <a:p>
+            <a:pPr>
+              <a:defRPr b="1" sz="1600">
+                <a:solidFill>
+                  <a:srgbClr val="3B82F6"/>
+                </a:solidFill>
+              </a:defRPr>
+            </a:pPr>
+            <a:r>
+              <a:t>• Layered Architecture Rule:</a:t>
+            </a:r>
+          </a:p>
+          <a:p>
+            <a:pPr>
+              <a:defRPr sz="1300">
+                <a:solidFill>
+                  <a:srgbClr val="F8FAFC"/>
+                </a:solidFill>
+              </a:defRPr>
+            </a:pPr>
+            <a:r>
+              <a:t>   layeredArchitecture().layer('Domain').layer('Application').layer('Infrastructure')</a:t>
+            </a:r>
+          </a:p>
+        </p:txBody>
+      </p:sp>
+    </p:spTree>
+  </p:cSld>
+  <p:clrMapOvr>
+    <a:masterClrMapping/>
+  </p:clrMapOvr>
+</p:sld>
+</file>
+
+<file path=ppt/slides/slide13.xml><?xml version="1.0" encoding="utf-8"?>
+<p:sld xmlns:a="http://schemas.openxmlformats.org/drawingml/2006/main" xmlns:p="http://schemas.openxmlformats.org/presentationml/2006/main" xmlns:r="http://schemas.openxmlformats.org/officeDocument/2006/relationships">
+  <p:cSld>
+    <p:bg>
+      <p:bgPr>
+        <a:solidFill>
+          <a:srgbClr val="0F172A"/>
+        </a:solidFill>
+        <a:effectLst/>
+      </p:bgPr>
+    </p:bg>
+    <p:spTree>
+      <p:nvGrpSpPr>
+        <p:cNvPr id="1" name=""/>
+        <p:cNvGrpSpPr/>
+        <p:nvPr/>
+      </p:nvGrpSpPr>
+      <p:grpSpPr/>
+      <p:sp>
+        <p:nvSpPr>
+          <p:cNvPr id="2" name="TextBox 1"/>
+          <p:cNvSpPr txBox="1"/>
+          <p:nvPr/>
+        </p:nvSpPr>
+        <p:spPr>
+          <a:xfrm>
+            <a:off x="731520" y="365760"/>
+            <a:ext cx="10698480" cy="822960"/>
+          </a:xfrm>
+          <a:prstGeom prst="rect">
+            <a:avLst/>
+          </a:prstGeom>
+          <a:noFill/>
+        </p:spPr>
+        <p:txBody>
+          <a:bodyPr wrap="square" lIns="0" tIns="0" rIns="0" bIns="0">
+            <a:spAutoFit/>
+          </a:bodyPr>
+          <a:lstStyle/>
+          <a:p>
+            <a:pPr>
+              <a:defRPr sz="1100" b="1">
+                <a:solidFill>
+                  <a:srgbClr val="3B82F6"/>
+                </a:solidFill>
+                <a:latin typeface="Arial"/>
+              </a:defRPr>
+            </a:pPr>
+            <a:r>
+              <a:t>PART 3 — ARCHUNIT ENFORCEMENT</a:t>
+            </a:r>
+          </a:p>
+          <a:p>
+            <a:pPr>
+              <a:defRPr sz="2400" b="1">
+                <a:solidFill>
+                  <a:srgbClr val="F8FAFC"/>
+                </a:solidFill>
+                <a:latin typeface="Arial"/>
+              </a:defRPr>
+            </a:pPr>
+            <a:r>
+              <a:t>How to Implement ArchUnit &amp; Challenges</a:t>
+            </a:r>
+          </a:p>
+        </p:txBody>
+      </p:sp>
+      <p:sp>
+        <p:nvSpPr>
+          <p:cNvPr id="3" name="TextBox 2"/>
+          <p:cNvSpPr txBox="1"/>
+          <p:nvPr/>
+        </p:nvSpPr>
+        <p:spPr>
+          <a:xfrm>
+            <a:off x="731520" y="1371600"/>
+            <a:ext cx="10698480" cy="4846320"/>
+          </a:xfrm>
+          <a:prstGeom prst="rect">
+            <a:avLst/>
+          </a:prstGeom>
+          <a:noFill/>
+        </p:spPr>
+        <p:txBody>
+          <a:bodyPr wrap="square">
+            <a:spAutoFit/>
+          </a:bodyPr>
+          <a:lstStyle/>
+          <a:p>
+            <a:pPr>
+              <a:defRPr b="1" sz="1800">
+                <a:solidFill>
+                  <a:srgbClr val="10B981"/>
+                </a:solidFill>
+              </a:defRPr>
+            </a:pPr>
+            <a:r>
+              <a:t>How to Implement ArchUnit:</a:t>
+            </a:r>
+          </a:p>
+          <a:p>
+            <a:pPr>
+              <a:defRPr sz="1400">
+                <a:solidFill>
+                  <a:srgbClr val="F8FAFC"/>
+                </a:solidFill>
+              </a:defRPr>
+            </a:pPr>
+            <a:r>
+              <a:t>  1. Add Maven Dependency: archunit-junit5 (v1.3.0) in pom.xml.</a:t>
+            </a:r>
+          </a:p>
+          <a:p>
+            <a:pPr>
+              <a:defRPr sz="1400">
+                <a:solidFill>
+                  <a:srgbClr val="F8FAFC"/>
+                </a:solidFill>
+              </a:defRPr>
+            </a:pPr>
+            <a:r>
+              <a:t>  1. Write Test Class: Annotate with @AnalyzeClasses(packages = 'com.satellite').</a:t>
+            </a:r>
+          </a:p>
+          <a:p>
+            <a:pPr>
+              <a:defRPr sz="1400">
+                <a:solidFill>
+                  <a:srgbClr val="F8FAFC"/>
+                </a:solidFill>
+              </a:defRPr>
+            </a:pPr>
+            <a:r>
+              <a:t>  1. Define Rules: Write static @ArchTest rules using ArchRuleDefinition DSL.</a:t>
+            </a:r>
+          </a:p>
+          <a:p>
+            <a:pPr>
+              <a:defRPr sz="1400">
+                <a:solidFill>
+                  <a:srgbClr val="F8FAFC"/>
+                </a:solidFill>
+              </a:defRPr>
+            </a:pPr>
+            <a:r>
+              <a:t>  1. Lifecycle Execution: Executes automatically post-compilation during mvn test before packaging!</a:t>
+            </a:r>
+          </a:p>
+          <a:p>
+            <a:br/>
+            <a:pPr>
+              <a:defRPr b="1" sz="1800">
+                <a:solidFill>
+                  <a:srgbClr val="F59E0B"/>
+                </a:solidFill>
+              </a:defRPr>
+            </a:pPr>
+            <a:r>
+              <a:t>Challenges &amp; Mitigations:</a:t>
+            </a:r>
+          </a:p>
+          <a:p>
+            <a:pPr>
+              <a:defRPr sz="1400">
+                <a:solidFill>
+                  <a:srgbClr val="F8FAFC"/>
+                </a:solidFill>
+              </a:defRPr>
+            </a:pPr>
+            <a:r>
+              <a:t>  • Retrofitting onto legacy codebases -&gt; Solved with FreezingArchRule to freeze existing violations.</a:t>
+            </a:r>
+          </a:p>
+          <a:p>
+            <a:pPr>
+              <a:defRPr sz="1400">
+                <a:solidFill>
+                  <a:srgbClr val="F8FAFC"/>
+                </a:solidFill>
+              </a:defRPr>
+            </a:pPr>
+            <a:r>
+              <a:t>  • Refactoring package structures -&gt; Update package string variables in HexagonalArchitectureTest.java.</a:t>
+            </a:r>
+          </a:p>
+        </p:txBody>
+      </p:sp>
+    </p:spTree>
+  </p:cSld>
+  <p:clrMapOvr>
+    <a:masterClrMapping/>
+  </p:clrMapOvr>
+</p:sld>
+</file>
+
+<file path=ppt/slides/slide14.xml><?xml version="1.0" encoding="utf-8"?>
+<p:sld xmlns:a="http://schemas.openxmlformats.org/drawingml/2006/main" xmlns:p="http://schemas.openxmlformats.org/presentationml/2006/main" xmlns:r="http://schemas.openxmlformats.org/officeDocument/2006/relationships">
+  <p:cSld>
+    <p:bg>
+      <p:bgPr>
+        <a:solidFill>
+          <a:srgbClr val="0F172A"/>
+        </a:solidFill>
+        <a:effectLst/>
+      </p:bgPr>
+    </p:bg>
+    <p:spTree>
+      <p:nvGrpSpPr>
+        <p:cNvPr id="1" name=""/>
+        <p:cNvGrpSpPr/>
+        <p:nvPr/>
+      </p:nvGrpSpPr>
+      <p:grpSpPr/>
+      <p:sp>
+        <p:nvSpPr>
+          <p:cNvPr id="2" name="TextBox 1"/>
+          <p:cNvSpPr txBox="1"/>
+          <p:nvPr/>
+        </p:nvSpPr>
+        <p:spPr>
+          <a:xfrm>
+            <a:off x="731520" y="365760"/>
+            <a:ext cx="10698480" cy="822960"/>
+          </a:xfrm>
+          <a:prstGeom prst="rect">
+            <a:avLst/>
+          </a:prstGeom>
+          <a:noFill/>
+        </p:spPr>
+        <p:txBody>
+          <a:bodyPr wrap="square" lIns="0" tIns="0" rIns="0" bIns="0">
+            <a:spAutoFit/>
+          </a:bodyPr>
+          <a:lstStyle/>
+          <a:p>
+            <a:pPr>
+              <a:defRPr sz="1100" b="1">
+                <a:solidFill>
+                  <a:srgbClr val="3B82F6"/>
+                </a:solidFill>
+                <a:latin typeface="Arial"/>
+              </a:defRPr>
+            </a:pPr>
+            <a:r>
+              <a:t>SUMMARY &amp; LIVE DEMO</a:t>
+            </a:r>
+          </a:p>
+          <a:p>
+            <a:pPr>
+              <a:defRPr sz="2400" b="1">
+                <a:solidFill>
+                  <a:srgbClr val="F8FAFC"/>
+                </a:solidFill>
+                <a:latin typeface="Arial"/>
+              </a:defRPr>
+            </a:pPr>
+            <a:r>
+              <a:t>Execution &amp; Live Demo Steps</a:t>
+            </a:r>
+          </a:p>
+        </p:txBody>
+      </p:sp>
+      <p:sp>
+        <p:nvSpPr>
+          <p:cNvPr id="3" name="TextBox 2"/>
+          <p:cNvSpPr txBox="1"/>
+          <p:nvPr/>
+        </p:nvSpPr>
+        <p:spPr>
+          <a:xfrm>
+            <a:off x="731520" y="1371600"/>
+            <a:ext cx="10698480" cy="4846320"/>
+          </a:xfrm>
+          <a:prstGeom prst="rect">
+            <a:avLst/>
+          </a:prstGeom>
+          <a:noFill/>
+        </p:spPr>
+        <p:txBody>
+          <a:bodyPr wrap="square">
+            <a:spAutoFit/>
+          </a:bodyPr>
+          <a:lstStyle/>
+          <a:p>
+            <a:pPr>
+              <a:defRPr b="1" sz="1600">
+                <a:solidFill>
+                  <a:srgbClr val="F59E0B"/>
+                </a:solidFill>
+              </a:defRPr>
+            </a:pPr>
+            <a:r>
+              <a:t>1. Run Automated Test Suite &amp; ArchUnit Build Gates:</a:t>
+            </a:r>
+          </a:p>
+          <a:p>
+            <a:pPr>
+              <a:defRPr sz="1400">
+                <a:solidFill>
+                  <a:srgbClr val="F8FAFC"/>
+                </a:solidFill>
+              </a:defRPr>
+            </a:pPr>
+            <a:r>
+              <a:t>  $ mvn clean test   # Executes 37 unit, integration &amp; ArchUnit tests (0 failures)</a:t>
+            </a:r>
+          </a:p>
+          <a:p>
+            <a:br/>
+            <a:pPr>
+              <a:defRPr b="1" sz="1600">
+                <a:solidFill>
+                  <a:srgbClr val="10B981"/>
+                </a:solidFill>
+              </a:defRPr>
+            </a:pPr>
+            <a:r>
+              <a:t>2. Run Spring Boot Application &amp; API Verification:</a:t>
+            </a:r>
+          </a:p>
+          <a:p>
+            <a:pPr>
+              <a:defRPr sz="1400">
+                <a:solidFill>
+                  <a:srgbClr val="F8FAFC"/>
+                </a:solidFill>
+              </a:defRPr>
+            </a:pPr>
+            <a:r>
+              <a:t>  $ mvn spring-boot:run</a:t>
+            </a:r>
+            <a:br/>
+            <a:r>
+              <a:t>  $ curl -X POST http://localhost:8080/api/v1/satellites -d '{...}'</a:t>
+            </a:r>
+          </a:p>
+          <a:p>
+            <a:br/>
+            <a:pPr>
+              <a:defRPr b="1" sz="1600">
+                <a:solidFill>
+                  <a:srgbClr val="3B82F6"/>
+                </a:solidFill>
+              </a:defRPr>
+            </a:pPr>
+            <a:r>
+              <a:t>3. Live Layer Conflict Demo (ArchUnit Build Failure):</a:t>
+            </a:r>
+          </a:p>
+          <a:p>
+            <a:pPr>
+              <a:defRPr sz="1400">
+                <a:solidFill>
+                  <a:srgbClr val="F8FAFC"/>
+                </a:solidFill>
+              </a:defRPr>
+            </a:pPr>
+            <a:r>
+              <a:t>  • Inject LaunchSatelliteService into SatelliteController.java</a:t>
+            </a:r>
+            <a:br/>
+            <a:r>
+              <a:t>  • Run mvn test -&gt; ArchUnit FAILS THE BUILD with explicit violation error report!</a:t>
+            </a:r>
+          </a:p>
+        </p:txBody>
+      </p:sp>
+    </p:spTree>
+  </p:cSld>
+  <p:clrMapOvr>
+    <a:masterClrMapping/>
+  </p:clrMapOvr>
+</p:sld>
+</file>
+
+<file path=ppt/slides/slide2.xml><?xml version="1.0" encoding="utf-8"?>
+<p:sld xmlns:a="http://schemas.openxmlformats.org/drawingml/2006/main" xmlns:p="http://schemas.openxmlformats.org/presentationml/2006/main" xmlns:r="http://schemas.openxmlformats.org/officeDocument/2006/relationships">
+  <p:cSld>
+    <p:bg>
+      <p:bgPr>
+        <a:solidFill>
+          <a:srgbClr val="0F172A"/>
+        </a:solidFill>
+        <a:effectLst/>
+      </p:bgPr>
+    </p:bg>
+    <p:spTree>
+      <p:nvGrpSpPr>
+        <p:cNvPr id="1" name=""/>
+        <p:cNvGrpSpPr/>
+        <p:nvPr/>
+      </p:nvGrpSpPr>
+      <p:grpSpPr/>
+      <p:sp>
+        <p:nvSpPr>
+          <p:cNvPr id="2" name="TextBox 1"/>
+          <p:cNvSpPr txBox="1"/>
+          <p:nvPr/>
+        </p:nvSpPr>
+        <p:spPr>
+          <a:xfrm>
+            <a:off x="731520" y="365760"/>
+            <a:ext cx="10698480" cy="822960"/>
+          </a:xfrm>
+          <a:prstGeom prst="rect">
+            <a:avLst/>
+          </a:prstGeom>
+          <a:noFill/>
+        </p:spPr>
+        <p:txBody>
+          <a:bodyPr wrap="square" lIns="0" tIns="0" rIns="0" bIns="0">
+            <a:spAutoFit/>
+          </a:bodyPr>
+          <a:lstStyle/>
+          <a:p>
+            <a:pPr>
+              <a:defRPr sz="1100" b="1">
+                <a:solidFill>
+                  <a:srgbClr val="3B82F6"/>
+                </a:solidFill>
+                <a:latin typeface="Arial"/>
+              </a:defRPr>
+            </a:pPr>
+            <a:r>
+              <a:t>PART 1 — DOMAIN-DRIVEN DESIGN</a:t>
+            </a:r>
+          </a:p>
+          <a:p>
+            <a:pPr>
+              <a:defRPr sz="2400" b="1">
+                <a:solidFill>
+                  <a:srgbClr val="F8FAFC"/>
+                </a:solidFill>
+                <a:latin typeface="Arial"/>
+              </a:defRPr>
+            </a:pPr>
+            <a:r>
+              <a:t>Domain-Driven Design (DDD): What &amp; Why</a:t>
+            </a:r>
+          </a:p>
+        </p:txBody>
+      </p:sp>
+      <p:sp>
+        <p:nvSpPr>
+          <p:cNvPr id="3" name="TextBox 2"/>
+          <p:cNvSpPr txBox="1"/>
+          <p:nvPr/>
+        </p:nvSpPr>
+        <p:spPr>
+          <a:xfrm>
+            <a:off x="731520" y="1371600"/>
+            <a:ext cx="10698480" cy="4846320"/>
+          </a:xfrm>
+          <a:prstGeom prst="rect">
+            <a:avLst/>
+          </a:prstGeom>
+          <a:noFill/>
+        </p:spPr>
+        <p:txBody>
+          <a:bodyPr wrap="square">
+            <a:spAutoFit/>
+          </a:bodyPr>
+          <a:lstStyle/>
+          <a:p>
+            <a:pPr>
+              <a:defRPr b="1" sz="2000">
+                <a:solidFill>
+                  <a:srgbClr val="F59E0B"/>
+                </a:solidFill>
+              </a:defRPr>
+            </a:pPr>
+            <a:r>
+              <a:t>What is Domain-Driven Design (DDD)?</a:t>
+            </a:r>
+          </a:p>
+          <a:p>
+            <a:pPr>
+              <a:defRPr sz="1500">
+                <a:solidFill>
+                  <a:srgbClr val="F8FAFC"/>
+                </a:solidFill>
+              </a:defRPr>
+            </a:pPr>
+            <a:r>
+              <a:t>• A software design approach focused on modeling software to match a complex business domain.</a:t>
+            </a:r>
+          </a:p>
+          <a:p>
+            <a:pPr>
+              <a:defRPr sz="1500">
+                <a:solidFill>
+                  <a:srgbClr val="F8FAFC"/>
+                </a:solidFill>
+              </a:defRPr>
+            </a:pPr>
+            <a:r>
+              <a:t>• Formulated by Eric Evans, it connects business experts and developers using a Ubiquitous Language.</a:t>
+            </a:r>
+          </a:p>
+          <a:p>
+            <a:br/>
+            <a:pPr>
+              <a:defRPr b="1" sz="2000">
+                <a:solidFill>
+                  <a:srgbClr val="10B981"/>
+                </a:solidFill>
+              </a:defRPr>
+            </a:pPr>
+            <a:r>
+              <a:t>Why Do We Need DDD?</a:t>
+            </a:r>
+          </a:p>
+          <a:p>
+            <a:pPr>
+              <a:defRPr sz="1500">
+                <a:solidFill>
+                  <a:srgbClr val="F8FAFC"/>
+                </a:solidFill>
+              </a:defRPr>
+            </a:pPr>
+            <a:r>
+              <a:t>• Eliminates Anemic Domain Models: Data objects are no longer dumb getters/setters; rules live in the domain.</a:t>
+            </a:r>
+          </a:p>
+          <a:p>
+            <a:pPr>
+              <a:defRPr sz="1500">
+                <a:solidFill>
+                  <a:srgbClr val="F8FAFC"/>
+                </a:solidFill>
+              </a:defRPr>
+            </a:pPr>
+            <a:r>
+              <a:t>• Bridges Communication Gap: Developers and business stakeholders use identical terminology.</a:t>
+            </a:r>
+          </a:p>
+          <a:p>
+            <a:pPr>
+              <a:defRPr sz="1500">
+                <a:solidFill>
+                  <a:srgbClr val="F8FAFC"/>
+                </a:solidFill>
+              </a:defRPr>
+            </a:pPr>
+            <a:r>
+              <a:t>• Prevents Architectural Decay: Isolates business rules so infrastructure changes don't corrupt domain logic.</a:t>
+            </a:r>
+          </a:p>
+        </p:txBody>
+      </p:sp>
+    </p:spTree>
+  </p:cSld>
+  <p:clrMapOvr>
+    <a:masterClrMapping/>
+  </p:clrMapOvr>
+</p:sld>
+</file>
+
 <file path=ppt/slides/slide3.xml><?xml version="1.0" encoding="utf-8"?>
 <p:sld xmlns:a="http://schemas.openxmlformats.org/drawingml/2006/main" xmlns:p="http://schemas.openxmlformats.org/presentationml/2006/main" xmlns:r="http://schemas.openxmlformats.org/officeDocument/2006/relationships">
   <p:cSld>
@@ -3317,7 +4259,7 @@
               </a:defRPr>
             </a:pPr>
             <a:r>
-              <a:t>WATA / HERBERTO GRAÇA SPECIFICATION</a:t>
+              <a:t>PART 1 — DOMAIN-DRIVEN DESIGN</a:t>
             </a:r>
           </a:p>
           <a:p>
@@ -3330,35 +4272,130 @@
               </a:defRPr>
             </a:pPr>
             <a:r>
-              <a:t>Hexagonal Architecture: Primary (Driving) &amp; Secondary (Driven) Adapters</a:t>
-            </a:r>
-          </a:p>
-        </p:txBody>
-      </p:sp>
-      <p:pic>
-        <p:nvPicPr>
-          <p:cNvPr id="3" name="Picture 2" descr="diagram_hexagonal_primary_secondary.png"/>
-          <p:cNvPicPr>
-            <a:picLocks noChangeAspect="1"/>
-          </p:cNvPicPr>
+              <a:t>DDD Components in Satellite System</a:t>
+            </a:r>
+          </a:p>
+        </p:txBody>
+      </p:sp>
+      <p:sp>
+        <p:nvSpPr>
+          <p:cNvPr id="3" name="TextBox 2"/>
+          <p:cNvSpPr txBox="1"/>
           <p:nvPr/>
-        </p:nvPicPr>
-        <p:blipFill>
-          <a:blip r:embed="rId2"/>
-          <a:stretch>
-            <a:fillRect/>
-          </a:stretch>
-        </p:blipFill>
+        </p:nvSpPr>
         <p:spPr>
           <a:xfrm>
-            <a:off x="731520" y="1280160"/>
-            <a:ext cx="10698480" cy="6017895"/>
+            <a:off x="731520" y="1371600"/>
+            <a:ext cx="10698480" cy="4846320"/>
           </a:xfrm>
           <a:prstGeom prst="rect">
             <a:avLst/>
           </a:prstGeom>
+          <a:noFill/>
         </p:spPr>
-      </p:pic>
+        <p:txBody>
+          <a:bodyPr wrap="square">
+            <a:spAutoFit/>
+          </a:bodyPr>
+          <a:lstStyle/>
+          <a:p>
+            <a:pPr>
+              <a:defRPr b="1" sz="1600">
+                <a:solidFill>
+                  <a:srgbClr val="3B82F6"/>
+                </a:solidFill>
+              </a:defRPr>
+            </a:pPr>
+            <a:r>
+              <a:t>• Aggregate Root (Satellite.java):</a:t>
+            </a:r>
+          </a:p>
+          <a:p>
+            <a:pPr>
+              <a:defRPr sz="1400">
+                <a:solidFill>
+                  <a:srgbClr val="F8FAFC"/>
+                </a:solidFill>
+              </a:defRPr>
+            </a:pPr>
+            <a:r>
+              <a:t>   Core entity managing state machine (REGISTERED -&gt; ACTIVE -&gt; ANOMALY -&gt; DECOMMISSIONED) &amp; invariant enforcement.</a:t>
+            </a:r>
+          </a:p>
+          <a:p>
+            <a:pPr>
+              <a:defRPr b="1" sz="1600">
+                <a:solidFill>
+                  <a:srgbClr val="3B82F6"/>
+                </a:solidFill>
+              </a:defRPr>
+            </a:pPr>
+            <a:r>
+              <a:t>• Value Objects (Orbit.java, Telemetry.java):</a:t>
+            </a:r>
+          </a:p>
+          <a:p>
+            <a:pPr>
+              <a:defRPr sz="1400">
+                <a:solidFill>
+                  <a:srgbClr val="F8FAFC"/>
+                </a:solidFill>
+              </a:defRPr>
+            </a:pPr>
+            <a:r>
+              <a:t>   Immutable JDK records with self-validation rules (LEO/GEO altitude checks, anomaly battery/temp thresholds).</a:t>
+            </a:r>
+          </a:p>
+          <a:p>
+            <a:pPr>
+              <a:defRPr b="1" sz="1600">
+                <a:solidFill>
+                  <a:srgbClr val="3B82F6"/>
+                </a:solidFill>
+              </a:defRPr>
+            </a:pPr>
+            <a:r>
+              <a:t>• Domain Events (SatelliteLaunchedEvent, AnomalyDetectedEvent):</a:t>
+            </a:r>
+          </a:p>
+          <a:p>
+            <a:pPr>
+              <a:defRPr sz="1400">
+                <a:solidFill>
+                  <a:srgbClr val="F8FAFC"/>
+                </a:solidFill>
+              </a:defRPr>
+            </a:pPr>
+            <a:r>
+              <a:t>   Immutable records representing facts that occurred in the domain, recorded internally by the aggregate.</a:t>
+            </a:r>
+          </a:p>
+          <a:p>
+            <a:pPr>
+              <a:defRPr b="1" sz="1600">
+                <a:solidFill>
+                  <a:srgbClr val="3B82F6"/>
+                </a:solidFill>
+              </a:defRPr>
+            </a:pPr>
+            <a:r>
+              <a:t>• Strongly-Typed Identity (SatelliteId.java):</a:t>
+            </a:r>
+          </a:p>
+          <a:p>
+            <a:pPr>
+              <a:defRPr sz="1400">
+                <a:solidFill>
+                  <a:srgbClr val="F8FAFC"/>
+                </a:solidFill>
+              </a:defRPr>
+            </a:pPr>
+            <a:r>
+              <a:t>   Record wrapping UUID to prevent primitive obsession and guarantee type safety across layers.</a:t>
+            </a:r>
+          </a:p>
+        </p:txBody>
+      </p:sp>
     </p:spTree>
   </p:cSld>
   <p:clrMapOvr>
@@ -3416,7 +4453,7 @@
               </a:defRPr>
             </a:pPr>
             <a:r>
-              <a:t>ARCHITECTURAL ISOLATION</a:t>
+              <a:t>PART 1 — DOMAIN-DRIVEN DESIGN</a:t>
             </a:r>
           </a:p>
           <a:p>
@@ -3429,35 +4466,131 @@
               </a:defRPr>
             </a:pPr>
             <a:r>
-              <a:t>Onion &amp; Hexagonal Concentric Ring Dependency Rules</a:t>
-            </a:r>
-          </a:p>
-        </p:txBody>
-      </p:sp>
-      <p:pic>
-        <p:nvPicPr>
-          <p:cNvPr id="3" name="Picture 2" descr="diagram_onion_concentric.png"/>
-          <p:cNvPicPr>
-            <a:picLocks noChangeAspect="1"/>
-          </p:cNvPicPr>
+              <a:t>How to Implement DDD &amp; Challenges</a:t>
+            </a:r>
+          </a:p>
+        </p:txBody>
+      </p:sp>
+      <p:sp>
+        <p:nvSpPr>
+          <p:cNvPr id="3" name="TextBox 2"/>
+          <p:cNvSpPr txBox="1"/>
           <p:nvPr/>
-        </p:nvPicPr>
-        <p:blipFill>
-          <a:blip r:embed="rId2"/>
-          <a:stretch>
-            <a:fillRect/>
-          </a:stretch>
-        </p:blipFill>
+        </p:nvSpPr>
         <p:spPr>
           <a:xfrm>
-            <a:off x="731520" y="1280160"/>
-            <a:ext cx="10698480" cy="6017895"/>
+            <a:off x="731520" y="1371600"/>
+            <a:ext cx="10698480" cy="4846320"/>
           </a:xfrm>
           <a:prstGeom prst="rect">
             <a:avLst/>
           </a:prstGeom>
+          <a:noFill/>
         </p:spPr>
-      </p:pic>
+        <p:txBody>
+          <a:bodyPr wrap="square">
+            <a:spAutoFit/>
+          </a:bodyPr>
+          <a:lstStyle/>
+          <a:p>
+            <a:pPr>
+              <a:defRPr b="1" sz="1800">
+                <a:solidFill>
+                  <a:srgbClr val="10B981"/>
+                </a:solidFill>
+              </a:defRPr>
+            </a:pPr>
+            <a:r>
+              <a:t>How to Implement DDD in Java 21:</a:t>
+            </a:r>
+          </a:p>
+          <a:p>
+            <a:pPr>
+              <a:defRPr sz="1400">
+                <a:solidFill>
+                  <a:srgbClr val="F8FAFC"/>
+                </a:solidFill>
+              </a:defRPr>
+            </a:pPr>
+            <a:r>
+              <a:t>  1. Pure Java Domain Model: Zero imports from Spring, JPA, or Jackson in com.satellite.domain.</a:t>
+            </a:r>
+          </a:p>
+          <a:p>
+            <a:pPr>
+              <a:defRPr sz="1400">
+                <a:solidFill>
+                  <a:srgbClr val="F8FAFC"/>
+                </a:solidFill>
+              </a:defRPr>
+            </a:pPr>
+            <a:r>
+              <a:t>  1. Java 21 Records: Use records for Value Objects and Domain Events to guarantee immutability.</a:t>
+            </a:r>
+          </a:p>
+          <a:p>
+            <a:pPr>
+              <a:defRPr sz="1400">
+                <a:solidFill>
+                  <a:srgbClr val="F8FAFC"/>
+                </a:solidFill>
+              </a:defRPr>
+            </a:pPr>
+            <a:r>
+              <a:t>  1. State Machine Encapsulation: Keep status transition logic private inside Satellite.java.</a:t>
+            </a:r>
+          </a:p>
+          <a:p>
+            <a:br/>
+            <a:pPr>
+              <a:defRPr b="1" sz="1800">
+                <a:solidFill>
+                  <a:srgbClr val="F59E0B"/>
+                </a:solidFill>
+              </a:defRPr>
+            </a:pPr>
+            <a:r>
+              <a:t>Challenges &amp; Mitigations:</a:t>
+            </a:r>
+          </a:p>
+          <a:p>
+            <a:pPr>
+              <a:defRPr sz="1400">
+                <a:solidFill>
+                  <a:srgbClr val="F8FAFC"/>
+                </a:solidFill>
+              </a:defRPr>
+            </a:pPr>
+            <a:r>
+              <a:t>  • Initial Learning Curve -&gt; Start with clear Bounded Contexts &amp; Ubiquitous Language glossary.</a:t>
+            </a:r>
+          </a:p>
+          <a:p>
+            <a:pPr>
+              <a:defRPr sz="1400">
+                <a:solidFill>
+                  <a:srgbClr val="F8FAFC"/>
+                </a:solidFill>
+              </a:defRPr>
+            </a:pPr>
+            <a:r>
+              <a:t>  • Over-engineering simple CRUD -&gt; Use DDD for core business domains; keep simple lookup tables light.</a:t>
+            </a:r>
+          </a:p>
+          <a:p>
+            <a:pPr>
+              <a:defRPr sz="1400">
+                <a:solidFill>
+                  <a:srgbClr val="F8FAFC"/>
+                </a:solidFill>
+              </a:defRPr>
+            </a:pPr>
+            <a:r>
+              <a:t>  • ORM Entity vs Domain Entity confusion -&gt; Explicitly separate SatelliteJpaEntity from Satellite.java aggregate.</a:t>
+            </a:r>
+          </a:p>
+        </p:txBody>
+      </p:sp>
     </p:spTree>
   </p:cSld>
   <p:clrMapOvr>
@@ -3515,7 +4648,7 @@
               </a:defRPr>
             </a:pPr>
             <a:r>
-              <a:t>DOMAIN DISTILLATION</a:t>
+              <a:t>PART 1 — DOMAIN-DRIVEN DESIGN</a:t>
             </a:r>
           </a:p>
           <a:p>
@@ -3528,7 +4661,7 @@
               </a:defRPr>
             </a:pPr>
             <a:r>
-              <a:t>Domain-Driven Design (DDD): Ubiquitous Language &amp; Subdomains</a:t>
+              <a:t>DDD Ubiquitous Language &amp; Subdomains Diagram</a:t>
             </a:r>
           </a:p>
         </p:txBody>
@@ -3614,7 +4747,7 @@
               </a:defRPr>
             </a:pPr>
             <a:r>
-              <a:t>ADAPTER LAYER FLEXIBILITY</a:t>
+              <a:t>PART 2 — HEXAGONAL ARCHITECTURE</a:t>
             </a:r>
           </a:p>
           <a:p>
@@ -3627,35 +4760,119 @@
               </a:defRPr>
             </a:pPr>
             <a:r>
-              <a:t>Hexagonal Superpower: Multi-Database Adapter Swapping Demo</a:t>
-            </a:r>
-          </a:p>
-        </p:txBody>
-      </p:sp>
-      <p:pic>
-        <p:nvPicPr>
-          <p:cNvPr id="3" name="Picture 2" descr="diagram_adapter_swapping.png"/>
-          <p:cNvPicPr>
-            <a:picLocks noChangeAspect="1"/>
-          </p:cNvPicPr>
+              <a:t>Hexagonal Architecture (Ports &amp; Adapters): What &amp; Why</a:t>
+            </a:r>
+          </a:p>
+        </p:txBody>
+      </p:sp>
+      <p:sp>
+        <p:nvSpPr>
+          <p:cNvPr id="3" name="TextBox 2"/>
+          <p:cNvSpPr txBox="1"/>
           <p:nvPr/>
-        </p:nvPicPr>
-        <p:blipFill>
-          <a:blip r:embed="rId2"/>
-          <a:stretch>
-            <a:fillRect/>
-          </a:stretch>
-        </p:blipFill>
+        </p:nvSpPr>
         <p:spPr>
           <a:xfrm>
-            <a:off x="731520" y="1280160"/>
-            <a:ext cx="10698480" cy="6017895"/>
+            <a:off x="731520" y="1371600"/>
+            <a:ext cx="10698480" cy="4846320"/>
           </a:xfrm>
           <a:prstGeom prst="rect">
             <a:avLst/>
           </a:prstGeom>
+          <a:noFill/>
         </p:spPr>
-      </p:pic>
+        <p:txBody>
+          <a:bodyPr wrap="square">
+            <a:spAutoFit/>
+          </a:bodyPr>
+          <a:lstStyle/>
+          <a:p>
+            <a:pPr>
+              <a:defRPr b="1" sz="2000">
+                <a:solidFill>
+                  <a:srgbClr val="F59E0B"/>
+                </a:solidFill>
+              </a:defRPr>
+            </a:pPr>
+            <a:r>
+              <a:t>What is Hexagonal Architecture?</a:t>
+            </a:r>
+          </a:p>
+          <a:p>
+            <a:pPr>
+              <a:defRPr sz="1500">
+                <a:solidFill>
+                  <a:srgbClr val="F8FAFC"/>
+                </a:solidFill>
+              </a:defRPr>
+            </a:pPr>
+            <a:r>
+              <a:t>• An architectural pattern created by Alistair Cockburn that isolates core application logic inside a Hexagon.</a:t>
+            </a:r>
+          </a:p>
+          <a:p>
+            <a:pPr>
+              <a:defRPr sz="1500">
+                <a:solidFill>
+                  <a:srgbClr val="F8FAFC"/>
+                </a:solidFill>
+              </a:defRPr>
+            </a:pPr>
+            <a:r>
+              <a:t>• Uses Ports (Interfaces) and Adapters (Implementations) so inputs and outputs can be plugged in seamlessly.</a:t>
+            </a:r>
+          </a:p>
+          <a:p>
+            <a:br/>
+            <a:pPr>
+              <a:defRPr b="1" sz="2000">
+                <a:solidFill>
+                  <a:srgbClr val="10B981"/>
+                </a:solidFill>
+              </a:defRPr>
+            </a:pPr>
+            <a:r>
+              <a:t>Why Do We Need Hexagonal Architecture?</a:t>
+            </a:r>
+          </a:p>
+          <a:p>
+            <a:pPr>
+              <a:defRPr sz="1500">
+                <a:solidFill>
+                  <a:srgbClr val="F8FAFC"/>
+                </a:solidFill>
+              </a:defRPr>
+            </a:pPr>
+            <a:r>
+              <a:t>• Decouples Business Logic from External Tools: Database, Web Frameworks, and MQ live outside the Hexagon.</a:t>
+            </a:r>
+          </a:p>
+          <a:p>
+            <a:pPr>
+              <a:defRPr sz="1500">
+                <a:solidFill>
+                  <a:srgbClr val="F8FAFC"/>
+                </a:solidFill>
+              </a:defRPr>
+            </a:pPr>
+            <a:r>
+              <a:t>• Enables Instant Testing: Domain logic is 100% testable in pure Java without booting Spring or DB (0.01s test execution).</a:t>
+            </a:r>
+          </a:p>
+          <a:p>
+            <a:pPr>
+              <a:defRPr sz="1500">
+                <a:solidFill>
+                  <a:srgbClr val="F8FAFC"/>
+                </a:solidFill>
+              </a:defRPr>
+            </a:pPr>
+            <a:r>
+              <a:t>• Prevents Technology Lock-in: Swap relational database (H2/Postgres) for MongoDB without changing domain code.</a:t>
+            </a:r>
+          </a:p>
+        </p:txBody>
+      </p:sp>
     </p:spTree>
   </p:cSld>
   <p:clrMapOvr>
@@ -3713,7 +4930,7 @@
               </a:defRPr>
             </a:pPr>
             <a:r>
-              <a:t>ARCHUNIT &amp; DEMO COMMANDS</a:t>
+              <a:t>PART 2 — HEXAGONAL ARCHITECTURE</a:t>
             </a:r>
           </a:p>
           <a:p>
@@ -3726,7 +4943,7 @@
               </a:defRPr>
             </a:pPr>
             <a:r>
-              <a:t>Automated Architecture Enforcement &amp; Testing</a:t>
+              <a:t>Hexagonal Components in Satellite System</a:t>
             </a:r>
           </a:p>
         </p:txBody>
@@ -3754,14 +4971,281 @@
           <a:lstStyle/>
           <a:p>
             <a:pPr>
+              <a:defRPr b="1" sz="1600">
+                <a:solidFill>
+                  <a:srgbClr val="3B82F6"/>
+                </a:solidFill>
+              </a:defRPr>
+            </a:pPr>
+            <a:r>
+              <a:t>• Driving Adapters (Inputs):</a:t>
+            </a:r>
+          </a:p>
+          <a:p>
+            <a:pPr>
+              <a:defRPr sz="1400">
+                <a:solidFill>
+                  <a:srgbClr val="F8FAFC"/>
+                </a:solidFill>
+              </a:defRPr>
+            </a:pPr>
+            <a:r>
+              <a:t>   SatelliteController.java (REST API) &amp; TelemetryConsumer.java (Kafka/CLI stream).</a:t>
+            </a:r>
+          </a:p>
+          <a:p>
+            <a:pPr>
+              <a:defRPr b="1" sz="1600">
+                <a:solidFill>
+                  <a:srgbClr val="3B82F6"/>
+                </a:solidFill>
+              </a:defRPr>
+            </a:pPr>
+            <a:r>
+              <a:t>• Driving Ports (Inbound Contracts):</a:t>
+            </a:r>
+          </a:p>
+          <a:p>
+            <a:pPr>
+              <a:defRPr sz="1400">
+                <a:solidFill>
+                  <a:srgbClr val="F8FAFC"/>
+                </a:solidFill>
+              </a:defRPr>
+            </a:pPr>
+            <a:r>
+              <a:t>   LaunchSatelliteUseCase.java &amp; UpdateTelemetryUseCase.java (Interfaces defined in domain.port.in).</a:t>
+            </a:r>
+          </a:p>
+          <a:p>
+            <a:pPr>
+              <a:defRPr b="1" sz="1600">
+                <a:solidFill>
+                  <a:srgbClr val="3B82F6"/>
+                </a:solidFill>
+              </a:defRPr>
+            </a:pPr>
+            <a:r>
+              <a:t>• Application Core:</a:t>
+            </a:r>
+          </a:p>
+          <a:p>
+            <a:pPr>
+              <a:defRPr sz="1400">
+                <a:solidFill>
+                  <a:srgbClr val="F8FAFC"/>
+                </a:solidFill>
+              </a:defRPr>
+            </a:pPr>
+            <a:r>
+              <a:t>   LaunchSatelliteService.java — Orchestrates domain objects via ports in pure Java.</a:t>
+            </a:r>
+          </a:p>
+          <a:p>
+            <a:pPr>
+              <a:defRPr b="1" sz="1600">
+                <a:solidFill>
+                  <a:srgbClr val="3B82F6"/>
+                </a:solidFill>
+              </a:defRPr>
+            </a:pPr>
+            <a:r>
+              <a:t>• Driven Ports (Outbound Contracts):</a:t>
+            </a:r>
+          </a:p>
+          <a:p>
+            <a:pPr>
+              <a:defRPr sz="1400">
+                <a:solidFill>
+                  <a:srgbClr val="F8FAFC"/>
+                </a:solidFill>
+              </a:defRPr>
+            </a:pPr>
+            <a:r>
+              <a:t>   SatelliteRepository.java &amp; SatelliteEventPublisher.java (Interfaces defined in domain.port.out).</a:t>
+            </a:r>
+          </a:p>
+          <a:p>
+            <a:pPr>
+              <a:defRPr b="1" sz="1600">
+                <a:solidFill>
+                  <a:srgbClr val="3B82F6"/>
+                </a:solidFill>
+              </a:defRPr>
+            </a:pPr>
+            <a:r>
+              <a:t>• Driven Adapters (Outputs):</a:t>
+            </a:r>
+          </a:p>
+          <a:p>
+            <a:pPr>
+              <a:defRPr sz="1400">
+                <a:solidFill>
+                  <a:srgbClr val="F8FAFC"/>
+                </a:solidFill>
+              </a:defRPr>
+            </a:pPr>
+            <a:r>
+              <a:t>   SatelliteJpaAdapter.java (SQL), SatelliteMongoAdapter.java (NoSQL), &amp; SatelliteEventPublisherAdapter.java.</a:t>
+            </a:r>
+          </a:p>
+        </p:txBody>
+      </p:sp>
+    </p:spTree>
+  </p:cSld>
+  <p:clrMapOvr>
+    <a:masterClrMapping/>
+  </p:clrMapOvr>
+</p:sld>
+</file>
+
+<file path=ppt/slides/slide8.xml><?xml version="1.0" encoding="utf-8"?>
+<p:sld xmlns:a="http://schemas.openxmlformats.org/drawingml/2006/main" xmlns:p="http://schemas.openxmlformats.org/presentationml/2006/main" xmlns:r="http://schemas.openxmlformats.org/officeDocument/2006/relationships">
+  <p:cSld>
+    <p:bg>
+      <p:bgPr>
+        <a:solidFill>
+          <a:srgbClr val="0F172A"/>
+        </a:solidFill>
+        <a:effectLst/>
+      </p:bgPr>
+    </p:bg>
+    <p:spTree>
+      <p:nvGrpSpPr>
+        <p:cNvPr id="1" name=""/>
+        <p:cNvGrpSpPr/>
+        <p:nvPr/>
+      </p:nvGrpSpPr>
+      <p:grpSpPr/>
+      <p:sp>
+        <p:nvSpPr>
+          <p:cNvPr id="2" name="TextBox 1"/>
+          <p:cNvSpPr txBox="1"/>
+          <p:nvPr/>
+        </p:nvSpPr>
+        <p:spPr>
+          <a:xfrm>
+            <a:off x="731520" y="365760"/>
+            <a:ext cx="10698480" cy="822960"/>
+          </a:xfrm>
+          <a:prstGeom prst="rect">
+            <a:avLst/>
+          </a:prstGeom>
+          <a:noFill/>
+        </p:spPr>
+        <p:txBody>
+          <a:bodyPr wrap="square" lIns="0" tIns="0" rIns="0" bIns="0">
+            <a:spAutoFit/>
+          </a:bodyPr>
+          <a:lstStyle/>
+          <a:p>
+            <a:pPr>
+              <a:defRPr sz="1100" b="1">
+                <a:solidFill>
+                  <a:srgbClr val="3B82F6"/>
+                </a:solidFill>
+                <a:latin typeface="Arial"/>
+              </a:defRPr>
+            </a:pPr>
+            <a:r>
+              <a:t>PART 2 — HEXAGONAL ARCHITECTURE</a:t>
+            </a:r>
+          </a:p>
+          <a:p>
+            <a:pPr>
+              <a:defRPr sz="2400" b="1">
+                <a:solidFill>
+                  <a:srgbClr val="F8FAFC"/>
+                </a:solidFill>
+                <a:latin typeface="Arial"/>
+              </a:defRPr>
+            </a:pPr>
+            <a:r>
+              <a:t>How to Implement Hexagonal Architecture &amp; Challenges</a:t>
+            </a:r>
+          </a:p>
+        </p:txBody>
+      </p:sp>
+      <p:sp>
+        <p:nvSpPr>
+          <p:cNvPr id="3" name="TextBox 2"/>
+          <p:cNvSpPr txBox="1"/>
+          <p:nvPr/>
+        </p:nvSpPr>
+        <p:spPr>
+          <a:xfrm>
+            <a:off x="731520" y="1371600"/>
+            <a:ext cx="10698480" cy="4846320"/>
+          </a:xfrm>
+          <a:prstGeom prst="rect">
+            <a:avLst/>
+          </a:prstGeom>
+          <a:noFill/>
+        </p:spPr>
+        <p:txBody>
+          <a:bodyPr wrap="square">
+            <a:spAutoFit/>
+          </a:bodyPr>
+          <a:lstStyle/>
+          <a:p>
+            <a:pPr>
               <a:defRPr b="1" sz="1800">
                 <a:solidFill>
+                  <a:srgbClr val="10B981"/>
+                </a:solidFill>
+              </a:defRPr>
+            </a:pPr>
+            <a:r>
+              <a:t>How to Implement Hexagonal Architecture:</a:t>
+            </a:r>
+          </a:p>
+          <a:p>
+            <a:pPr>
+              <a:defRPr sz="1400">
+                <a:solidFill>
+                  <a:srgbClr val="F8FAFC"/>
+                </a:solidFill>
+              </a:defRPr>
+            </a:pPr>
+            <a:r>
+              <a:t>  1. Package Structure: com.satellite.domain, com.satellite.application, com.satellite.infrastructure.</a:t>
+            </a:r>
+          </a:p>
+          <a:p>
+            <a:pPr>
+              <a:defRPr sz="1400">
+                <a:solidFill>
+                  <a:srgbClr val="F8FAFC"/>
+                </a:solidFill>
+              </a:defRPr>
+            </a:pPr>
+            <a:r>
+              <a:t>  1. Inward Dependencies: Infrastructure depends on Application &amp; Domain; Domain depends on NOTHING.</a:t>
+            </a:r>
+          </a:p>
+          <a:p>
+            <a:pPr>
+              <a:defRPr sz="1400">
+                <a:solidFill>
+                  <a:srgbClr val="F8FAFC"/>
+                </a:solidFill>
+              </a:defRPr>
+            </a:pPr>
+            <a:r>
+              <a:t>  1. Bean Composition Root: Wire services and adapters in BeanConfig.java inside infrastructure package.</a:t>
+            </a:r>
+          </a:p>
+          <a:p>
+            <a:br/>
+            <a:pPr>
+              <a:defRPr b="1" sz="1800">
+                <a:solidFill>
                   <a:srgbClr val="F59E0B"/>
                 </a:solidFill>
               </a:defRPr>
             </a:pPr>
             <a:r>
-              <a:t>1. ArchUnit Build Gates (11 Mandatory Rules):</a:t>
+              <a:t>Challenges &amp; Mitigations:</a:t>
             </a:r>
           </a:p>
           <a:p>
@@ -3773,7 +5257,7 @@
               </a:defRPr>
             </a:pPr>
             <a:r>
-              <a:t>  • Domain Purity: domain has zero dependencies on infrastructure, application, Spring, or JPA.</a:t>
+              <a:t>  • Mapping Overhead (Domain &lt;-&gt; DTO &lt;-&gt; JPA Entity) -&gt; Solved with dedicated mappers (SatellitePersistenceMapper).</a:t>
             </a:r>
           </a:p>
           <a:p>
@@ -3785,7 +5269,7 @@
               </a:defRPr>
             </a:pPr>
             <a:r>
-              <a:t>  • Port Isolation: Inbound &amp; Outbound ports reside strictly in domain.port package.</a:t>
+              <a:t>  • More interfaces &amp; classes -&gt; Solved by clear package isolation (ports/in, ports/out).</a:t>
             </a:r>
           </a:p>
           <a:p>
@@ -3797,72 +5281,110 @@
               </a:defRPr>
             </a:pPr>
             <a:r>
-              <a:t>  • Controller Constraint: REST controllers depend ONLY on inbound ports (LaunchSatelliteUseCase).</a:t>
-            </a:r>
-          </a:p>
-          <a:p>
-            <a:pPr>
-              <a:defRPr sz="1400">
-                <a:solidFill>
-                  <a:srgbClr val="F8FAFC"/>
-                </a:solidFill>
-              </a:defRPr>
-            </a:pPr>
-            <a:r>
-              <a:t>  • Adapter Isolation: Driving adapters (REST) cannot call driven adapters (JPA).</a:t>
-            </a:r>
-          </a:p>
-          <a:p>
-            <a:br/>
-            <a:pPr>
-              <a:defRPr b="1" sz="1800">
-                <a:solidFill>
-                  <a:srgbClr val="10B981"/>
-                </a:solidFill>
-              </a:defRPr>
-            </a:pPr>
-            <a:r>
-              <a:t>2. Execution &amp; Live Demo Commands:</a:t>
-            </a:r>
-          </a:p>
-          <a:p>
-            <a:pPr>
-              <a:defRPr sz="1400">
-                <a:solidFill>
-                  <a:srgbClr val="F8FAFC"/>
-                </a:solidFill>
-              </a:defRPr>
-            </a:pPr>
-            <a:r>
-              <a:t>  $ mvn clean test               # Runs 37 unit, integration &amp; ArchUnit tests (0 failures)</a:t>
-            </a:r>
-          </a:p>
-          <a:p>
-            <a:pPr>
-              <a:defRPr sz="1400">
-                <a:solidFill>
-                  <a:srgbClr val="F8FAFC"/>
-                </a:solidFill>
-              </a:defRPr>
-            </a:pPr>
-            <a:r>
-              <a:t>  $ mvn spring-boot:run          # Launches live Spring Boot REST application on http://localhost:8080</a:t>
-            </a:r>
-          </a:p>
-          <a:p>
-            <a:pPr>
-              <a:defRPr sz="1400">
-                <a:solidFill>
-                  <a:srgbClr val="F8FAFC"/>
-                </a:solidFill>
-              </a:defRPr>
-            </a:pPr>
-            <a:r>
-              <a:t>  $ curl -X POST .../satellites  # Launches new satellite &amp; persists via SatelliteRepository port</a:t>
-            </a:r>
-          </a:p>
-        </p:txBody>
-      </p:sp>
+              <a:t>  • Risk of developers bypassing ports -&gt; Solved by ArchUnit automated architecture build gates!</a:t>
+            </a:r>
+          </a:p>
+        </p:txBody>
+      </p:sp>
+    </p:spTree>
+  </p:cSld>
+  <p:clrMapOvr>
+    <a:masterClrMapping/>
+  </p:clrMapOvr>
+</p:sld>
+</file>
+
+<file path=ppt/slides/slide9.xml><?xml version="1.0" encoding="utf-8"?>
+<p:sld xmlns:a="http://schemas.openxmlformats.org/drawingml/2006/main" xmlns:p="http://schemas.openxmlformats.org/presentationml/2006/main" xmlns:r="http://schemas.openxmlformats.org/officeDocument/2006/relationships">
+  <p:cSld>
+    <p:bg>
+      <p:bgPr>
+        <a:solidFill>
+          <a:srgbClr val="0F172A"/>
+        </a:solidFill>
+        <a:effectLst/>
+      </p:bgPr>
+    </p:bg>
+    <p:spTree>
+      <p:nvGrpSpPr>
+        <p:cNvPr id="1" name=""/>
+        <p:cNvGrpSpPr/>
+        <p:nvPr/>
+      </p:nvGrpSpPr>
+      <p:grpSpPr/>
+      <p:sp>
+        <p:nvSpPr>
+          <p:cNvPr id="2" name="TextBox 1"/>
+          <p:cNvSpPr txBox="1"/>
+          <p:nvPr/>
+        </p:nvSpPr>
+        <p:spPr>
+          <a:xfrm>
+            <a:off x="731520" y="365760"/>
+            <a:ext cx="10698480" cy="822960"/>
+          </a:xfrm>
+          <a:prstGeom prst="rect">
+            <a:avLst/>
+          </a:prstGeom>
+          <a:noFill/>
+        </p:spPr>
+        <p:txBody>
+          <a:bodyPr wrap="square" lIns="0" tIns="0" rIns="0" bIns="0">
+            <a:spAutoFit/>
+          </a:bodyPr>
+          <a:lstStyle/>
+          <a:p>
+            <a:pPr>
+              <a:defRPr sz="1100" b="1">
+                <a:solidFill>
+                  <a:srgbClr val="3B82F6"/>
+                </a:solidFill>
+                <a:latin typeface="Arial"/>
+              </a:defRPr>
+            </a:pPr>
+            <a:r>
+              <a:t>PART 2 — HEXAGONAL ARCHITECTURE</a:t>
+            </a:r>
+          </a:p>
+          <a:p>
+            <a:pPr>
+              <a:defRPr sz="2400" b="1">
+                <a:solidFill>
+                  <a:srgbClr val="F8FAFC"/>
+                </a:solidFill>
+                <a:latin typeface="Arial"/>
+              </a:defRPr>
+            </a:pPr>
+            <a:r>
+              <a:t>Herberto Graça Explicit Architecture Mapping</a:t>
+            </a:r>
+          </a:p>
+        </p:txBody>
+      </p:sp>
+      <p:pic>
+        <p:nvPicPr>
+          <p:cNvPr id="3" name="Picture 2" descr="diagram_explicit_architecture.png"/>
+          <p:cNvPicPr>
+            <a:picLocks noChangeAspect="1"/>
+          </p:cNvPicPr>
+          <p:nvPr/>
+        </p:nvPicPr>
+        <p:blipFill>
+          <a:blip r:embed="rId2"/>
+          <a:stretch>
+            <a:fillRect/>
+          </a:stretch>
+        </p:blipFill>
+        <p:spPr>
+          <a:xfrm>
+            <a:off x="731520" y="1280160"/>
+            <a:ext cx="10698480" cy="6017895"/>
+          </a:xfrm>
+          <a:prstGeom prst="rect">
+            <a:avLst/>
+          </a:prstGeom>
+        </p:spPr>
+      </p:pic>
     </p:spTree>
   </p:cSld>
   <p:clrMapOvr>

</xml_diff>